<commit_message>
Propuesta: "esta mañana" pasa a "precio estimado" en la presentación
Co-Authored-By: Claude Opus 5.5 <noreply@anthropic.com>
Claude-Session: https://claude.ai/code/session_01K4euaCdGeGEi9bYZHon2WY
</commit_message>
<xml_diff>
--- a/propuesta/Precios Grupo Azullab.pptx
+++ b/propuesta/Precios Grupo Azullab.pptx
@@ -123,37 +123,37 @@
   <p:extLst>
     <p:ext uri="{521415D9-36F7-43E2-AB2F-B90AF26B5E84}">
       <p14:sectionLst xmlns:p14="http://schemas.microsoft.com/office/powerpoint/2010/main">
-        <p14:section name="Inicio" id="{47543ba0-7fbe-4d6a-7dd0-3afa111e98d1}">
+        <p14:section name="Inicio" id="{d6a0c574-6ffc-4dff-3874-ce7e5149cabe}">
           <p14:sldIdLst>
             <p14:sldId id="256"/>
           </p14:sldIdLst>
         </p14:section>
-        <p14:section name="Qué trae" id="{98a42553-e3b7-1f5b-4cb5-0d8c92ae3712}">
+        <p14:section name="Qué trae" id="{cd4bb5e0-6a18-ee93-a8da-e1ac06589b92}">
           <p14:sldIdLst>
             <p14:sldId id="257"/>
             <p14:sldId id="258"/>
           </p14:sldIdLst>
         </p14:section>
-        <p14:section name="Precios de esta mañana" id="{c9867837-ce27-57c8-36e5-e2ae2455b7b6}">
+        <p14:section name="Precio estimado" id="{628b073d-67c7-6a9b-1fc2-23a69be6d7ce}">
           <p14:sldIdLst>
             <p14:sldId id="259"/>
             <p14:sldId id="260"/>
           </p14:sldIdLst>
         </p14:section>
-        <p14:section name="Dos opciones nuevas" id="{47cd3e93-17e1-cb4d-fc3c-1084b27474ac}">
+        <p14:section name="Dos opciones nuevas" id="{9eb82ca3-8fd1-2a5c-40a0-0fc7588d0b44}">
           <p14:sldIdLst>
             <p14:sldId id="261"/>
             <p14:sldId id="262"/>
           </p14:sldIdLst>
         </p14:section>
-        <p14:section name="La diferencia" id="{3ab47de4-a873-8877-e1dc-1fa63fcf0a31}">
+        <p14:section name="La diferencia" id="{4dec71fb-2c79-03e1-b24a-70e4c402bbac}">
           <p14:sldIdLst>
             <p14:sldId id="263"/>
             <p14:sldId id="264"/>
             <p14:sldId id="265"/>
           </p14:sldIdLst>
         </p14:section>
-        <p14:section name="Costos y tiempos" id="{3b618566-db69-d7a8-3984-b4e88e99c581}">
+        <p14:section name="Costos y tiempos" id="{b02094f5-37a6-ce35-2020-3a28f391be4b}">
           <p14:sldIdLst>
             <p14:sldId id="266"/>
             <p14:sldId id="267"/>
@@ -163,7 +163,7 @@
             <p14:sldId id="271"/>
           </p14:sldIdLst>
         </p14:section>
-        <p14:section name="Cierre" id="{72a63a1a-9f97-c4b5-dd49-87fddd7d1d3b}">
+        <p14:section name="Cierre" id="{87ea320a-15ad-6568-94cf-196337976a33}">
           <p14:sldIdLst>
             <p14:sldId id="272"/>
           </p14:sldIdLst>
@@ -225,7 +225,7 @@
               <c:strCache>
                 <c:ptCount val="1"/>
                 <c:pt idx="0">
-                  <c:v>Esta mañana</c:v>
+                  <c:v>Precio estimado</c:v>
                 </c:pt>
               </c:strCache>
             </c:strRef>
@@ -866,7 +866,7 @@
                 <c:ptCount val="3"/>
                 <c:lvl>
                   <c:pt idx="0">
-                    <c:v>Esta mañana ($130)</c:v>
+                    <c:v>Precio estimado ($130)</c:v>
                   </c:pt>
                   <c:pt idx="1">
                     <c:v>Opción A ($90)</c:v>
@@ -949,7 +949,7 @@
                 <c:ptCount val="3"/>
                 <c:lvl>
                   <c:pt idx="0">
-                    <c:v>Esta mañana ($130)</c:v>
+                    <c:v>Precio estimado ($130)</c:v>
                   </c:pt>
                   <c:pt idx="1">
                     <c:v>Opción A ($90)</c:v>
@@ -3948,7 +3948,7 @@
                   <a:schemeClr val="tx2"/>
                 </a:solidFill>
               </a:rPr>
-              <a:t>Año por año, frente a los precios de esta mañana</a:t>
+              <a:t>Año por año, frente al precio estimado</a:t>
             </a:r>
             <a:endParaRPr lang="en-US" sz="2800" dirty="0"/>
           </a:p>
@@ -4057,7 +4057,7 @@
                           <a:ea typeface="Calibri" pitchFamily="34" charset="-122"/>
                           <a:cs typeface="Calibri" pitchFamily="34" charset="-120"/>
                         </a:rPr>
-                        <a:t>Esta mañana</a:t>
+                        <a:t>Estimado</a:t>
                       </a:r>
                       <a:endParaRPr lang="en-US" sz="1300" dirty="0">
                         <a:latin typeface="Calibri" charset="0"/>
@@ -8811,7 +8811,7 @@
                           <a:ea typeface="Calibri" pitchFamily="34" charset="-122"/>
                           <a:cs typeface="Calibri" pitchFamily="34" charset="-120"/>
                         </a:rPr>
-                        <a:t>Esta mañana</a:t>
+                        <a:t>Precio estimado</a:t>
                       </a:r>
                       <a:endParaRPr lang="en-US" sz="1400" dirty="0">
                         <a:latin typeface="Calibri" charset="0"/>
@@ -9476,7 +9476,7 @@
                 <a:ea typeface="Calibri" pitchFamily="34" charset="-122"/>
                 <a:cs typeface="Calibri" pitchFamily="34" charset="-120"/>
               </a:rPr>
-              <a:t>Deja $44 a $69 al mes, pero sin pago inicial las ≈ 380 horas de construcción no se cobran al principio. En 3 años suma $3.240, 46 % menos que los precios de esta mañana.</a:t>
+              <a:t>Deja $44 a $69 al mes, pero sin pago inicial las ≈ 380 horas de construcción no se cobran al principio. En 3 años suma $3.240, 46 % menos que el precio estimado.</a:t>
             </a:r>
             <a:endParaRPr lang="en-US" sz="1400" dirty="0"/>
           </a:p>
@@ -11810,7 +11810,7 @@
                   <a:schemeClr val="bg1"/>
                 </a:solidFill>
               </a:rPr>
-              <a:t>1 · Los precios de esta mañana</a:t>
+              <a:t>1 · El precio estimado</a:t>
             </a:r>
             <a:endParaRPr lang="en-US" sz="3600" dirty="0"/>
           </a:p>
@@ -11956,7 +11956,7 @@
                   <a:schemeClr val="tx2"/>
                 </a:solidFill>
               </a:rPr>
-              <a:t>Precios de esta mañana: $2.910 el primer año</a:t>
+              <a:t>Precio estimado: $2.910 el primer año</a:t>
             </a:r>
             <a:endParaRPr lang="en-US" sz="2800" dirty="0"/>
           </a:p>
@@ -15359,7 +15359,7 @@
                 <a:ea typeface="Calibri" pitchFamily="34" charset="-122"/>
                 <a:cs typeface="Calibri" pitchFamily="34" charset="-120"/>
               </a:rPr>
-              <a:t>3 años con los precios de esta mañana</a:t>
+              <a:t>3 años con el precio estimado</a:t>
             </a:r>
             <a:endParaRPr lang="en-US" sz="1200" dirty="0"/>
           </a:p>

</xml_diff>

<commit_message>
Propuesta: costos de Vercel, Supabase y dominio al mes y al año; primer mes gratis con pago inicial
Co-Authored-By: Claude Opus 5.5 <noreply@anthropic.com>
Claude-Session: https://claude.ai/code/session_01K4euaCdGeGEi9bYZHon2WY
</commit_message>
<xml_diff>
--- a/propuesta/Precios Grupo Azullab.pptx
+++ b/propuesta/Precios Grupo Azullab.pptx
@@ -123,37 +123,37 @@
   <p:extLst>
     <p:ext uri="{521415D9-36F7-43E2-AB2F-B90AF26B5E84}">
       <p14:sectionLst xmlns:p14="http://schemas.microsoft.com/office/powerpoint/2010/main">
-        <p14:section name="Inicio" id="{d6a0c574-6ffc-4dff-3874-ce7e5149cabe}">
+        <p14:section name="Inicio" id="{ac7a0818-e564-38d5-e81e-1e7e67e840b1}">
           <p14:sldIdLst>
             <p14:sldId id="256"/>
           </p14:sldIdLst>
         </p14:section>
-        <p14:section name="Qué trae" id="{cd4bb5e0-6a18-ee93-a8da-e1ac06589b92}">
+        <p14:section name="Qué trae" id="{291be22a-3a40-7ce2-b81c-4f0f9e4793de}">
           <p14:sldIdLst>
             <p14:sldId id="257"/>
             <p14:sldId id="258"/>
           </p14:sldIdLst>
         </p14:section>
-        <p14:section name="Precio estimado" id="{628b073d-67c7-6a9b-1fc2-23a69be6d7ce}">
+        <p14:section name="Precio estimado" id="{b05f0a13-7411-138a-0d81-1474fc65316f}">
           <p14:sldIdLst>
             <p14:sldId id="259"/>
             <p14:sldId id="260"/>
           </p14:sldIdLst>
         </p14:section>
-        <p14:section name="Dos opciones nuevas" id="{9eb82ca3-8fd1-2a5c-40a0-0fc7588d0b44}">
+        <p14:section name="Dos opciones nuevas" id="{50e7c18e-ae9d-8327-14e4-8f53f8a4afbd}">
           <p14:sldIdLst>
             <p14:sldId id="261"/>
             <p14:sldId id="262"/>
           </p14:sldIdLst>
         </p14:section>
-        <p14:section name="La diferencia" id="{4dec71fb-2c79-03e1-b24a-70e4c402bbac}">
+        <p14:section name="La diferencia" id="{da7e9332-ac1c-66fa-514a-d5eaa0bb6196}">
           <p14:sldIdLst>
             <p14:sldId id="263"/>
             <p14:sldId id="264"/>
             <p14:sldId id="265"/>
           </p14:sldIdLst>
         </p14:section>
-        <p14:section name="Costos y tiempos" id="{b02094f5-37a6-ce35-2020-3a28f391be4b}">
+        <p14:section name="Costos y tiempos" id="{34060b93-a9b9-3340-5c02-e0e53b698446}">
           <p14:sldIdLst>
             <p14:sldId id="266"/>
             <p14:sldId id="267"/>
@@ -163,7 +163,7 @@
             <p14:sldId id="271"/>
           </p14:sldIdLst>
         </p14:section>
-        <p14:section name="Cierre" id="{87ea320a-15ad-6568-94cf-196337976a33}">
+        <p14:section name="Cierre" id="{ffca145f-cbba-0126-b7c8-fe8af166c04a}">
           <p14:sldIdLst>
             <p14:sldId id="272"/>
           </p14:sldIdLst>
@@ -590,22 +590,22 @@
                   <c:v>550</c:v>
                 </c:pt>
                 <c:pt idx="1">
-                  <c:v>760</c:v>
+                  <c:v>725</c:v>
                 </c:pt>
                 <c:pt idx="2">
-                  <c:v>970</c:v>
+                  <c:v>935</c:v>
                 </c:pt>
                 <c:pt idx="3">
-                  <c:v>1180</c:v>
+                  <c:v>1145</c:v>
                 </c:pt>
                 <c:pt idx="4">
-                  <c:v>1390</c:v>
+                  <c:v>1355</c:v>
                 </c:pt>
                 <c:pt idx="5">
-                  <c:v>1600</c:v>
+                  <c:v>1565</c:v>
                 </c:pt>
                 <c:pt idx="6">
-                  <c:v>1810</c:v>
+                  <c:v>1775</c:v>
                 </c:pt>
               </c:numCache>
             </c:numRef>
@@ -2769,7 +2769,7 @@
           <a:p>
             <a:r>
               <a:rPr lang="en-US" dirty="0"/>
-              <a:t>Supuesto: el CrossFit va gratis en las dos opciones, sin instalación y sin mensualidad. Opción A: $90 al mes por 12 meses. Opción B: $550 de instalación y $35 al mes.</a:t>
+              <a:t>Supuesto: el CrossFit va gratis en las dos opciones, sin instalación y sin mensualidad. Opción A: $90 al mes por 12 meses. Opción B: $550 de instalación y $35 al mes, con el primer mes gratis (11 mensualidades el primer año).</a:t>
             </a:r>
             <a:endParaRPr lang="en-US" dirty="0"/>
           </a:p>
@@ -4982,7 +4982,7 @@
                           <a:ea typeface="Calibri" pitchFamily="34" charset="-122"/>
                           <a:cs typeface="Calibri" pitchFamily="34" charset="-120"/>
                         </a:rPr>
-                        <a:t>$970  (-67 %)</a:t>
+                        <a:t>$935  (-68 %)</a:t>
                       </a:r>
                       <a:endParaRPr lang="en-US" sz="1400" dirty="0">
                         <a:latin typeface="Calibri" charset="0"/>
@@ -5506,7 +5506,7 @@
                           <a:ea typeface="Calibri" pitchFamily="34" charset="-122"/>
                           <a:cs typeface="Calibri" pitchFamily="34" charset="-120"/>
                         </a:rPr>
-                        <a:t>$1.810  (-70 %)</a:t>
+                        <a:t>$1.775  (-71 %)</a:t>
                       </a:r>
                       <a:endParaRPr lang="en-US" sz="1400" dirty="0">
                         <a:latin typeface="Calibri" charset="0"/>
@@ -5592,7 +5592,7 @@
                 <a:ea typeface="Calibri" pitchFamily="34" charset="-122"/>
                 <a:cs typeface="Calibri" pitchFamily="34" charset="-120"/>
               </a:rPr>
-              <a:t>La opción A alcanza a la B en el mes 10 y desde ahí cobra $55 más cada mes. Pero la B no obliga a quedarse: si el cliente se va al mes 6, la A ya habría cobrado $540 y la B $760.</a:t>
+              <a:t>La opción A alcanza a la B en el mes 10 y desde ahí cobra $55 más cada mes. Pero la B no obliga a quedarse: si el cliente se va al mes 6, la A ya habría cobrado $540 y la B $725 (con el primer mes gratis).</a:t>
             </a:r>
             <a:endParaRPr lang="en-US" sz="1300" dirty="0"/>
           </a:p>
@@ -7770,7 +7770,7 @@
               <a:buNone/>
             </a:pPr>
             <a:r>
-              <a:rPr lang="en-US" sz="3600" b="1" dirty="0">
+              <a:rPr lang="en-US" sz="3000" b="1" dirty="0">
                 <a:solidFill>
                   <a:srgbClr val="FFFFFF"/>
                 </a:solidFill>
@@ -7778,9 +7778,9 @@
                 <a:ea typeface="Cambria" pitchFamily="34" charset="-122"/>
                 <a:cs typeface="Cambria" pitchFamily="34" charset="-120"/>
               </a:rPr>
-              <a:t>≈ $3.800</a:t>
+              <a:t>≈ 9 semanas</a:t>
             </a:r>
-            <a:endParaRPr lang="en-US" sz="3600" dirty="0"/>
+            <a:endParaRPr lang="en-US" sz="3000" dirty="0"/>
           </a:p>
         </p:txBody>
       </p:sp>
@@ -7792,8 +7792,8 @@
         </p:nvSpPr>
         <p:spPr>
           <a:xfrm>
-            <a:off x="6172200" y="2286000"/>
-            <a:ext cx="2377440" cy="1097280"/>
+            <a:off x="6172200" y="2240280"/>
+            <a:ext cx="2377440" cy="1371600"/>
           </a:xfrm>
           <a:prstGeom prst="rect">
             <a:avLst/>
@@ -7817,7 +7817,7 @@
                 <a:ea typeface="Calibri" pitchFamily="34" charset="-122"/>
                 <a:cs typeface="Calibri" pitchFamily="34" charset="-120"/>
               </a:rPr>
-              <a:t>Valor de esas horas a $10 la hora. El pago inicial es lo que cubre esta construcción.</a:t>
+              <a:t>Son horas de trabajo, no un gasto en efectivo. Las cubre el pago inicial o, sin pago inicial, las mensualidades del compromiso anual.</a:t>
             </a:r>
             <a:endParaRPr lang="en-US" sz="1400" dirty="0"/>
           </a:p>
@@ -7964,22 +7964,1878 @@
                   <a:schemeClr val="tx2"/>
                 </a:solidFill>
               </a:rPr>
-              <a:t>Mantenerlo cuesta $21 a $46 al mes y 14 horas</a:t>
+              <a:t>Lo que se paga para mantenerlo en línea</a:t>
             </a:r>
             <a:endParaRPr lang="en-US" sz="2800" dirty="0"/>
           </a:p>
         </p:txBody>
       </p:sp>
-      <p:sp>
-        <p:nvSpPr>
-          <p:cNvPr id="3" name="Text 1"/>
+      <p:graphicFrame>
+        <p:nvGraphicFramePr>
+          <p:cNvPr id="15" name="Table 0"/>
+          <p:cNvGraphicFramePr>
+            <a:graphicFrameLocks noGrp="1"/>
+          </p:cNvGraphicFramePr>
+          <p:nvPr>
+            <p:extLst>
+              <p:ext uri="{D42A27DB-BD31-4B8C-83A1-F6EECF244321}">
+                <p14:modId xmlns:p14="http://schemas.microsoft.com/office/powerpoint/2010/main" val="1579011935"/>
+              </p:ext>
+            </p:extLst>
+          </p:nvPr>
+        </p:nvGraphicFramePr>
+        <p:xfrm>
+          <a:off x="457200" y="1097280"/>
+          <a:ext cx="5029200" cy="914400"/>
+        </p:xfrm>
+        <a:graphic>
+          <a:graphicData uri="http://schemas.openxmlformats.org/drawingml/2006/table">
+            <a:tbl>
+              <a:tblPr/>
+              <a:tblGrid>
+                <a:gridCol w="1691640"/>
+                <a:gridCol w="1828800"/>
+                <a:gridCol w="685800"/>
+                <a:gridCol w="822960"/>
+              </a:tblGrid>
+              <a:tr h="365760">
+                <a:tc>
+                  <a:txBody>
+                    <a:bodyPr/>
+                    <a:lstStyle/>
+                    <a:p>
+                      <a:pPr indent="0" marL="0">
+                        <a:buNone/>
+                      </a:pPr>
+                      <a:r>
+                        <a:rPr lang="en-US" sz="1300" b="1" dirty="0">
+                          <a:solidFill>
+                            <a:srgbClr val="FFFFFF"/>
+                          </a:solidFill>
+                          <a:latin typeface="Calibri" pitchFamily="34" charset="0"/>
+                          <a:ea typeface="Calibri" pitchFamily="34" charset="-122"/>
+                          <a:cs typeface="Calibri" pitchFamily="34" charset="-120"/>
+                        </a:rPr>
+                        <a:t>Servicio</a:t>
+                      </a:r>
+                      <a:endParaRPr lang="en-US" sz="1300" dirty="0">
+                        <a:latin typeface="Calibri" charset="0"/>
+                        <a:ea typeface="Calibri" charset="0"/>
+                        <a:cs typeface="Calibri" charset="0"/>
+                      </a:endParaRPr>
+                    </a:p>
+                  </a:txBody>
+                  <a:tcPr marL="36576" marR="36576" marT="36576" marB="36576" anchor="ctr">
+                    <a:lnL w="9525" cap="flat" cmpd="sng" algn="ctr">
+                      <a:solidFill>
+                        <a:srgbClr val="CBD8EA"/>
+                      </a:solidFill>
+                      <a:prstDash val="solid"/>
+                      <a:round/>
+                      <a:headEnd type="none" w="med" len="med"/>
+                      <a:tailEnd type="none" w="med" len="med"/>
+                    </a:lnL>
+                    <a:lnR w="9525" cap="flat" cmpd="sng" algn="ctr">
+                      <a:solidFill>
+                        <a:srgbClr val="CBD8EA"/>
+                      </a:solidFill>
+                      <a:prstDash val="solid"/>
+                      <a:round/>
+                      <a:headEnd type="none" w="med" len="med"/>
+                      <a:tailEnd type="none" w="med" len="med"/>
+                    </a:lnR>
+                    <a:lnT w="9525" cap="flat" cmpd="sng" algn="ctr">
+                      <a:solidFill>
+                        <a:srgbClr val="CBD8EA"/>
+                      </a:solidFill>
+                      <a:prstDash val="solid"/>
+                      <a:round/>
+                      <a:headEnd type="none" w="med" len="med"/>
+                      <a:tailEnd type="none" w="med" len="med"/>
+                    </a:lnT>
+                    <a:lnB w="9525" cap="flat" cmpd="sng" algn="ctr">
+                      <a:solidFill>
+                        <a:srgbClr val="CBD8EA"/>
+                      </a:solidFill>
+                      <a:prstDash val="solid"/>
+                      <a:round/>
+                      <a:headEnd type="none" w="med" len="med"/>
+                      <a:tailEnd type="none" w="med" len="med"/>
+                    </a:lnB>
+                    <a:solidFill>
+                      <a:srgbClr val="0E1752"/>
+                    </a:solidFill>
+                  </a:tcPr>
+                </a:tc>
+                <a:tc>
+                  <a:txBody>
+                    <a:bodyPr/>
+                    <a:lstStyle/>
+                    <a:p>
+                      <a:pPr indent="0" marL="0">
+                        <a:buNone/>
+                      </a:pPr>
+                      <a:r>
+                        <a:rPr lang="en-US" sz="1300" b="1" dirty="0">
+                          <a:solidFill>
+                            <a:srgbClr val="FFFFFF"/>
+                          </a:solidFill>
+                          <a:latin typeface="Calibri" pitchFamily="34" charset="0"/>
+                          <a:ea typeface="Calibri" pitchFamily="34" charset="-122"/>
+                          <a:cs typeface="Calibri" pitchFamily="34" charset="-120"/>
+                        </a:rPr>
+                        <a:t>Para qué</a:t>
+                      </a:r>
+                      <a:endParaRPr lang="en-US" sz="1300" dirty="0">
+                        <a:latin typeface="Calibri" charset="0"/>
+                        <a:ea typeface="Calibri" charset="0"/>
+                        <a:cs typeface="Calibri" charset="0"/>
+                      </a:endParaRPr>
+                    </a:p>
+                  </a:txBody>
+                  <a:tcPr marL="36576" marR="36576" marT="36576" marB="36576" anchor="ctr">
+                    <a:lnL w="9525" cap="flat" cmpd="sng" algn="ctr">
+                      <a:solidFill>
+                        <a:srgbClr val="CBD8EA"/>
+                      </a:solidFill>
+                      <a:prstDash val="solid"/>
+                      <a:round/>
+                      <a:headEnd type="none" w="med" len="med"/>
+                      <a:tailEnd type="none" w="med" len="med"/>
+                    </a:lnL>
+                    <a:lnR w="9525" cap="flat" cmpd="sng" algn="ctr">
+                      <a:solidFill>
+                        <a:srgbClr val="CBD8EA"/>
+                      </a:solidFill>
+                      <a:prstDash val="solid"/>
+                      <a:round/>
+                      <a:headEnd type="none" w="med" len="med"/>
+                      <a:tailEnd type="none" w="med" len="med"/>
+                    </a:lnR>
+                    <a:lnT w="9525" cap="flat" cmpd="sng" algn="ctr">
+                      <a:solidFill>
+                        <a:srgbClr val="CBD8EA"/>
+                      </a:solidFill>
+                      <a:prstDash val="solid"/>
+                      <a:round/>
+                      <a:headEnd type="none" w="med" len="med"/>
+                      <a:tailEnd type="none" w="med" len="med"/>
+                    </a:lnT>
+                    <a:lnB w="9525" cap="flat" cmpd="sng" algn="ctr">
+                      <a:solidFill>
+                        <a:srgbClr val="CBD8EA"/>
+                      </a:solidFill>
+                      <a:prstDash val="solid"/>
+                      <a:round/>
+                      <a:headEnd type="none" w="med" len="med"/>
+                      <a:tailEnd type="none" w="med" len="med"/>
+                    </a:lnB>
+                    <a:solidFill>
+                      <a:srgbClr val="0E1752"/>
+                    </a:solidFill>
+                  </a:tcPr>
+                </a:tc>
+                <a:tc>
+                  <a:txBody>
+                    <a:bodyPr/>
+                    <a:lstStyle/>
+                    <a:p>
+                      <a:pPr indent="0" marL="0">
+                        <a:buNone/>
+                      </a:pPr>
+                      <a:r>
+                        <a:rPr lang="en-US" sz="1300" b="1" dirty="0">
+                          <a:solidFill>
+                            <a:srgbClr val="FFFFFF"/>
+                          </a:solidFill>
+                          <a:latin typeface="Calibri" pitchFamily="34" charset="0"/>
+                          <a:ea typeface="Calibri" pitchFamily="34" charset="-122"/>
+                          <a:cs typeface="Calibri" pitchFamily="34" charset="-120"/>
+                        </a:rPr>
+                        <a:t>Al mes</a:t>
+                      </a:r>
+                      <a:endParaRPr lang="en-US" sz="1300" dirty="0">
+                        <a:latin typeface="Calibri" charset="0"/>
+                        <a:ea typeface="Calibri" charset="0"/>
+                        <a:cs typeface="Calibri" charset="0"/>
+                      </a:endParaRPr>
+                    </a:p>
+                  </a:txBody>
+                  <a:tcPr marL="36576" marR="36576" marT="36576" marB="36576" anchor="ctr">
+                    <a:lnL w="9525" cap="flat" cmpd="sng" algn="ctr">
+                      <a:solidFill>
+                        <a:srgbClr val="CBD8EA"/>
+                      </a:solidFill>
+                      <a:prstDash val="solid"/>
+                      <a:round/>
+                      <a:headEnd type="none" w="med" len="med"/>
+                      <a:tailEnd type="none" w="med" len="med"/>
+                    </a:lnL>
+                    <a:lnR w="9525" cap="flat" cmpd="sng" algn="ctr">
+                      <a:solidFill>
+                        <a:srgbClr val="CBD8EA"/>
+                      </a:solidFill>
+                      <a:prstDash val="solid"/>
+                      <a:round/>
+                      <a:headEnd type="none" w="med" len="med"/>
+                      <a:tailEnd type="none" w="med" len="med"/>
+                    </a:lnR>
+                    <a:lnT w="9525" cap="flat" cmpd="sng" algn="ctr">
+                      <a:solidFill>
+                        <a:srgbClr val="CBD8EA"/>
+                      </a:solidFill>
+                      <a:prstDash val="solid"/>
+                      <a:round/>
+                      <a:headEnd type="none" w="med" len="med"/>
+                      <a:tailEnd type="none" w="med" len="med"/>
+                    </a:lnT>
+                    <a:lnB w="9525" cap="flat" cmpd="sng" algn="ctr">
+                      <a:solidFill>
+                        <a:srgbClr val="CBD8EA"/>
+                      </a:solidFill>
+                      <a:prstDash val="solid"/>
+                      <a:round/>
+                      <a:headEnd type="none" w="med" len="med"/>
+                      <a:tailEnd type="none" w="med" len="med"/>
+                    </a:lnB>
+                    <a:solidFill>
+                      <a:srgbClr val="0E1752"/>
+                    </a:solidFill>
+                  </a:tcPr>
+                </a:tc>
+                <a:tc>
+                  <a:txBody>
+                    <a:bodyPr/>
+                    <a:lstStyle/>
+                    <a:p>
+                      <a:pPr indent="0" marL="0">
+                        <a:buNone/>
+                      </a:pPr>
+                      <a:r>
+                        <a:rPr lang="en-US" sz="1300" b="1" dirty="0">
+                          <a:solidFill>
+                            <a:srgbClr val="FFFFFF"/>
+                          </a:solidFill>
+                          <a:latin typeface="Calibri" pitchFamily="34" charset="0"/>
+                          <a:ea typeface="Calibri" pitchFamily="34" charset="-122"/>
+                          <a:cs typeface="Calibri" pitchFamily="34" charset="-120"/>
+                        </a:rPr>
+                        <a:t>Al año</a:t>
+                      </a:r>
+                      <a:endParaRPr lang="en-US" sz="1300" dirty="0">
+                        <a:latin typeface="Calibri" charset="0"/>
+                        <a:ea typeface="Calibri" charset="0"/>
+                        <a:cs typeface="Calibri" charset="0"/>
+                      </a:endParaRPr>
+                    </a:p>
+                  </a:txBody>
+                  <a:tcPr marL="36576" marR="36576" marT="36576" marB="36576" anchor="ctr">
+                    <a:lnL w="9525" cap="flat" cmpd="sng" algn="ctr">
+                      <a:solidFill>
+                        <a:srgbClr val="CBD8EA"/>
+                      </a:solidFill>
+                      <a:prstDash val="solid"/>
+                      <a:round/>
+                      <a:headEnd type="none" w="med" len="med"/>
+                      <a:tailEnd type="none" w="med" len="med"/>
+                    </a:lnL>
+                    <a:lnR w="9525" cap="flat" cmpd="sng" algn="ctr">
+                      <a:solidFill>
+                        <a:srgbClr val="CBD8EA"/>
+                      </a:solidFill>
+                      <a:prstDash val="solid"/>
+                      <a:round/>
+                      <a:headEnd type="none" w="med" len="med"/>
+                      <a:tailEnd type="none" w="med" len="med"/>
+                    </a:lnR>
+                    <a:lnT w="9525" cap="flat" cmpd="sng" algn="ctr">
+                      <a:solidFill>
+                        <a:srgbClr val="CBD8EA"/>
+                      </a:solidFill>
+                      <a:prstDash val="solid"/>
+                      <a:round/>
+                      <a:headEnd type="none" w="med" len="med"/>
+                      <a:tailEnd type="none" w="med" len="med"/>
+                    </a:lnT>
+                    <a:lnB w="9525" cap="flat" cmpd="sng" algn="ctr">
+                      <a:solidFill>
+                        <a:srgbClr val="CBD8EA"/>
+                      </a:solidFill>
+                      <a:prstDash val="solid"/>
+                      <a:round/>
+                      <a:headEnd type="none" w="med" len="med"/>
+                      <a:tailEnd type="none" w="med" len="med"/>
+                    </a:lnB>
+                    <a:solidFill>
+                      <a:srgbClr val="0E1752"/>
+                    </a:solidFill>
+                  </a:tcPr>
+                </a:tc>
+              </a:tr>
+              <a:tr h="365760">
+                <a:tc>
+                  <a:txBody>
+                    <a:bodyPr/>
+                    <a:lstStyle/>
+                    <a:p>
+                      <a:pPr indent="0" marL="0">
+                        <a:buNone/>
+                      </a:pPr>
+                      <a:r>
+                        <a:rPr lang="en-US" sz="1200" dirty="0">
+                          <a:solidFill>
+                            <a:srgbClr val="14183A"/>
+                          </a:solidFill>
+                          <a:latin typeface="Calibri" pitchFamily="34" charset="0"/>
+                          <a:ea typeface="Calibri" pitchFamily="34" charset="-122"/>
+                          <a:cs typeface="Calibri" pitchFamily="34" charset="-120"/>
+                        </a:rPr>
+                        <a:t>Vercel Pro</a:t>
+                      </a:r>
+                      <a:endParaRPr lang="en-US" sz="1200" dirty="0">
+                        <a:latin typeface="Calibri" charset="0"/>
+                        <a:ea typeface="Calibri" charset="0"/>
+                        <a:cs typeface="Calibri" charset="0"/>
+                      </a:endParaRPr>
+                    </a:p>
+                  </a:txBody>
+                  <a:tcPr marL="36576" marR="36576" marT="36576" marB="36576" anchor="ctr">
+                    <a:lnL w="9525" cap="flat" cmpd="sng" algn="ctr">
+                      <a:solidFill>
+                        <a:srgbClr val="CBD8EA"/>
+                      </a:solidFill>
+                      <a:prstDash val="solid"/>
+                      <a:round/>
+                      <a:headEnd type="none" w="med" len="med"/>
+                      <a:tailEnd type="none" w="med" len="med"/>
+                    </a:lnL>
+                    <a:lnR w="9525" cap="flat" cmpd="sng" algn="ctr">
+                      <a:solidFill>
+                        <a:srgbClr val="CBD8EA"/>
+                      </a:solidFill>
+                      <a:prstDash val="solid"/>
+                      <a:round/>
+                      <a:headEnd type="none" w="med" len="med"/>
+                      <a:tailEnd type="none" w="med" len="med"/>
+                    </a:lnR>
+                    <a:lnT w="9525" cap="flat" cmpd="sng" algn="ctr">
+                      <a:solidFill>
+                        <a:srgbClr val="CBD8EA"/>
+                      </a:solidFill>
+                      <a:prstDash val="solid"/>
+                      <a:round/>
+                      <a:headEnd type="none" w="med" len="med"/>
+                      <a:tailEnd type="none" w="med" len="med"/>
+                    </a:lnT>
+                    <a:lnB w="9525" cap="flat" cmpd="sng" algn="ctr">
+                      <a:solidFill>
+                        <a:srgbClr val="CBD8EA"/>
+                      </a:solidFill>
+                      <a:prstDash val="solid"/>
+                      <a:round/>
+                      <a:headEnd type="none" w="med" len="med"/>
+                      <a:tailEnd type="none" w="med" len="med"/>
+                    </a:lnB>
+                  </a:tcPr>
+                </a:tc>
+                <a:tc>
+                  <a:txBody>
+                    <a:bodyPr/>
+                    <a:lstStyle/>
+                    <a:p>
+                      <a:pPr indent="0" marL="0">
+                        <a:buNone/>
+                      </a:pPr>
+                      <a:r>
+                        <a:rPr lang="en-US" sz="1200" dirty="0">
+                          <a:solidFill>
+                            <a:srgbClr val="14183A"/>
+                          </a:solidFill>
+                          <a:latin typeface="Calibri" pitchFamily="34" charset="0"/>
+                          <a:ea typeface="Calibri" pitchFamily="34" charset="-122"/>
+                          <a:cs typeface="Calibri" pitchFamily="34" charset="-120"/>
+                        </a:rPr>
+                        <a:t>Aloja los tres sistemas</a:t>
+                      </a:r>
+                      <a:endParaRPr lang="en-US" sz="1200" dirty="0">
+                        <a:latin typeface="Calibri" charset="0"/>
+                        <a:ea typeface="Calibri" charset="0"/>
+                        <a:cs typeface="Calibri" charset="0"/>
+                      </a:endParaRPr>
+                    </a:p>
+                  </a:txBody>
+                  <a:tcPr marL="36576" marR="36576" marT="36576" marB="36576" anchor="ctr">
+                    <a:lnL w="9525" cap="flat" cmpd="sng" algn="ctr">
+                      <a:solidFill>
+                        <a:srgbClr val="CBD8EA"/>
+                      </a:solidFill>
+                      <a:prstDash val="solid"/>
+                      <a:round/>
+                      <a:headEnd type="none" w="med" len="med"/>
+                      <a:tailEnd type="none" w="med" len="med"/>
+                    </a:lnL>
+                    <a:lnR w="9525" cap="flat" cmpd="sng" algn="ctr">
+                      <a:solidFill>
+                        <a:srgbClr val="CBD8EA"/>
+                      </a:solidFill>
+                      <a:prstDash val="solid"/>
+                      <a:round/>
+                      <a:headEnd type="none" w="med" len="med"/>
+                      <a:tailEnd type="none" w="med" len="med"/>
+                    </a:lnR>
+                    <a:lnT w="9525" cap="flat" cmpd="sng" algn="ctr">
+                      <a:solidFill>
+                        <a:srgbClr val="CBD8EA"/>
+                      </a:solidFill>
+                      <a:prstDash val="solid"/>
+                      <a:round/>
+                      <a:headEnd type="none" w="med" len="med"/>
+                      <a:tailEnd type="none" w="med" len="med"/>
+                    </a:lnT>
+                    <a:lnB w="9525" cap="flat" cmpd="sng" algn="ctr">
+                      <a:solidFill>
+                        <a:srgbClr val="CBD8EA"/>
+                      </a:solidFill>
+                      <a:prstDash val="solid"/>
+                      <a:round/>
+                      <a:headEnd type="none" w="med" len="med"/>
+                      <a:tailEnd type="none" w="med" len="med"/>
+                    </a:lnB>
+                  </a:tcPr>
+                </a:tc>
+                <a:tc>
+                  <a:txBody>
+                    <a:bodyPr/>
+                    <a:lstStyle/>
+                    <a:p>
+                      <a:pPr indent="0" marL="0">
+                        <a:buNone/>
+                      </a:pPr>
+                      <a:r>
+                        <a:rPr lang="en-US" sz="1200" dirty="0">
+                          <a:solidFill>
+                            <a:srgbClr val="14183A"/>
+                          </a:solidFill>
+                          <a:latin typeface="Calibri" pitchFamily="34" charset="0"/>
+                          <a:ea typeface="Calibri" pitchFamily="34" charset="-122"/>
+                          <a:cs typeface="Calibri" pitchFamily="34" charset="-120"/>
+                        </a:rPr>
+                        <a:t>$20</a:t>
+                      </a:r>
+                      <a:endParaRPr lang="en-US" sz="1200" dirty="0">
+                        <a:latin typeface="Calibri" charset="0"/>
+                        <a:ea typeface="Calibri" charset="0"/>
+                        <a:cs typeface="Calibri" charset="0"/>
+                      </a:endParaRPr>
+                    </a:p>
+                  </a:txBody>
+                  <a:tcPr marL="36576" marR="36576" marT="36576" marB="36576" anchor="ctr">
+                    <a:lnL w="9525" cap="flat" cmpd="sng" algn="ctr">
+                      <a:solidFill>
+                        <a:srgbClr val="CBD8EA"/>
+                      </a:solidFill>
+                      <a:prstDash val="solid"/>
+                      <a:round/>
+                      <a:headEnd type="none" w="med" len="med"/>
+                      <a:tailEnd type="none" w="med" len="med"/>
+                    </a:lnL>
+                    <a:lnR w="9525" cap="flat" cmpd="sng" algn="ctr">
+                      <a:solidFill>
+                        <a:srgbClr val="CBD8EA"/>
+                      </a:solidFill>
+                      <a:prstDash val="solid"/>
+                      <a:round/>
+                      <a:headEnd type="none" w="med" len="med"/>
+                      <a:tailEnd type="none" w="med" len="med"/>
+                    </a:lnR>
+                    <a:lnT w="9525" cap="flat" cmpd="sng" algn="ctr">
+                      <a:solidFill>
+                        <a:srgbClr val="CBD8EA"/>
+                      </a:solidFill>
+                      <a:prstDash val="solid"/>
+                      <a:round/>
+                      <a:headEnd type="none" w="med" len="med"/>
+                      <a:tailEnd type="none" w="med" len="med"/>
+                    </a:lnT>
+                    <a:lnB w="9525" cap="flat" cmpd="sng" algn="ctr">
+                      <a:solidFill>
+                        <a:srgbClr val="CBD8EA"/>
+                      </a:solidFill>
+                      <a:prstDash val="solid"/>
+                      <a:round/>
+                      <a:headEnd type="none" w="med" len="med"/>
+                      <a:tailEnd type="none" w="med" len="med"/>
+                    </a:lnB>
+                  </a:tcPr>
+                </a:tc>
+                <a:tc>
+                  <a:txBody>
+                    <a:bodyPr/>
+                    <a:lstStyle/>
+                    <a:p>
+                      <a:pPr indent="0" marL="0">
+                        <a:buNone/>
+                      </a:pPr>
+                      <a:r>
+                        <a:rPr lang="en-US" sz="1200" dirty="0">
+                          <a:solidFill>
+                            <a:srgbClr val="14183A"/>
+                          </a:solidFill>
+                          <a:latin typeface="Calibri" pitchFamily="34" charset="0"/>
+                          <a:ea typeface="Calibri" pitchFamily="34" charset="-122"/>
+                          <a:cs typeface="Calibri" pitchFamily="34" charset="-120"/>
+                        </a:rPr>
+                        <a:t>$240</a:t>
+                      </a:r>
+                      <a:endParaRPr lang="en-US" sz="1200" dirty="0">
+                        <a:latin typeface="Calibri" charset="0"/>
+                        <a:ea typeface="Calibri" charset="0"/>
+                        <a:cs typeface="Calibri" charset="0"/>
+                      </a:endParaRPr>
+                    </a:p>
+                  </a:txBody>
+                  <a:tcPr marL="36576" marR="36576" marT="36576" marB="36576" anchor="ctr">
+                    <a:lnL w="9525" cap="flat" cmpd="sng" algn="ctr">
+                      <a:solidFill>
+                        <a:srgbClr val="CBD8EA"/>
+                      </a:solidFill>
+                      <a:prstDash val="solid"/>
+                      <a:round/>
+                      <a:headEnd type="none" w="med" len="med"/>
+                      <a:tailEnd type="none" w="med" len="med"/>
+                    </a:lnL>
+                    <a:lnR w="9525" cap="flat" cmpd="sng" algn="ctr">
+                      <a:solidFill>
+                        <a:srgbClr val="CBD8EA"/>
+                      </a:solidFill>
+                      <a:prstDash val="solid"/>
+                      <a:round/>
+                      <a:headEnd type="none" w="med" len="med"/>
+                      <a:tailEnd type="none" w="med" len="med"/>
+                    </a:lnR>
+                    <a:lnT w="9525" cap="flat" cmpd="sng" algn="ctr">
+                      <a:solidFill>
+                        <a:srgbClr val="CBD8EA"/>
+                      </a:solidFill>
+                      <a:prstDash val="solid"/>
+                      <a:round/>
+                      <a:headEnd type="none" w="med" len="med"/>
+                      <a:tailEnd type="none" w="med" len="med"/>
+                    </a:lnT>
+                    <a:lnB w="9525" cap="flat" cmpd="sng" algn="ctr">
+                      <a:solidFill>
+                        <a:srgbClr val="CBD8EA"/>
+                      </a:solidFill>
+                      <a:prstDash val="solid"/>
+                      <a:round/>
+                      <a:headEnd type="none" w="med" len="med"/>
+                      <a:tailEnd type="none" w="med" len="med"/>
+                    </a:lnB>
+                  </a:tcPr>
+                </a:tc>
+              </a:tr>
+              <a:tr h="365760">
+                <a:tc>
+                  <a:txBody>
+                    <a:bodyPr/>
+                    <a:lstStyle/>
+                    <a:p>
+                      <a:pPr indent="0" marL="0">
+                        <a:buNone/>
+                      </a:pPr>
+                      <a:r>
+                        <a:rPr lang="en-US" sz="1200" dirty="0">
+                          <a:solidFill>
+                            <a:srgbClr val="14183A"/>
+                          </a:solidFill>
+                          <a:latin typeface="Calibri" pitchFamily="34" charset="0"/>
+                          <a:ea typeface="Calibri" pitchFamily="34" charset="-122"/>
+                          <a:cs typeface="Calibri" pitchFamily="34" charset="-120"/>
+                        </a:rPr>
+                        <a:t>Supabase, plan gratis</a:t>
+                      </a:r>
+                      <a:endParaRPr lang="en-US" sz="1200" dirty="0">
+                        <a:latin typeface="Calibri" charset="0"/>
+                        <a:ea typeface="Calibri" charset="0"/>
+                        <a:cs typeface="Calibri" charset="0"/>
+                      </a:endParaRPr>
+                    </a:p>
+                  </a:txBody>
+                  <a:tcPr marL="36576" marR="36576" marT="36576" marB="36576" anchor="ctr">
+                    <a:lnL w="9525" cap="flat" cmpd="sng" algn="ctr">
+                      <a:solidFill>
+                        <a:srgbClr val="CBD8EA"/>
+                      </a:solidFill>
+                      <a:prstDash val="solid"/>
+                      <a:round/>
+                      <a:headEnd type="none" w="med" len="med"/>
+                      <a:tailEnd type="none" w="med" len="med"/>
+                    </a:lnL>
+                    <a:lnR w="9525" cap="flat" cmpd="sng" algn="ctr">
+                      <a:solidFill>
+                        <a:srgbClr val="CBD8EA"/>
+                      </a:solidFill>
+                      <a:prstDash val="solid"/>
+                      <a:round/>
+                      <a:headEnd type="none" w="med" len="med"/>
+                      <a:tailEnd type="none" w="med" len="med"/>
+                    </a:lnR>
+                    <a:lnT w="9525" cap="flat" cmpd="sng" algn="ctr">
+                      <a:solidFill>
+                        <a:srgbClr val="CBD8EA"/>
+                      </a:solidFill>
+                      <a:prstDash val="solid"/>
+                      <a:round/>
+                      <a:headEnd type="none" w="med" len="med"/>
+                      <a:tailEnd type="none" w="med" len="med"/>
+                    </a:lnT>
+                    <a:lnB w="9525" cap="flat" cmpd="sng" algn="ctr">
+                      <a:solidFill>
+                        <a:srgbClr val="CBD8EA"/>
+                      </a:solidFill>
+                      <a:prstDash val="solid"/>
+                      <a:round/>
+                      <a:headEnd type="none" w="med" len="med"/>
+                      <a:tailEnd type="none" w="med" len="med"/>
+                    </a:lnB>
+                  </a:tcPr>
+                </a:tc>
+                <a:tc>
+                  <a:txBody>
+                    <a:bodyPr/>
+                    <a:lstStyle/>
+                    <a:p>
+                      <a:pPr indent="0" marL="0">
+                        <a:buNone/>
+                      </a:pPr>
+                      <a:r>
+                        <a:rPr lang="en-US" sz="1200" dirty="0">
+                          <a:solidFill>
+                            <a:srgbClr val="14183A"/>
+                          </a:solidFill>
+                          <a:latin typeface="Calibri" pitchFamily="34" charset="0"/>
+                          <a:ea typeface="Calibri" pitchFamily="34" charset="-122"/>
+                          <a:cs typeface="Calibri" pitchFamily="34" charset="-120"/>
+                        </a:rPr>
+                        <a:t>Base de datos de los tres RIF</a:t>
+                      </a:r>
+                      <a:endParaRPr lang="en-US" sz="1200" dirty="0">
+                        <a:latin typeface="Calibri" charset="0"/>
+                        <a:ea typeface="Calibri" charset="0"/>
+                        <a:cs typeface="Calibri" charset="0"/>
+                      </a:endParaRPr>
+                    </a:p>
+                  </a:txBody>
+                  <a:tcPr marL="36576" marR="36576" marT="36576" marB="36576" anchor="ctr">
+                    <a:lnL w="9525" cap="flat" cmpd="sng" algn="ctr">
+                      <a:solidFill>
+                        <a:srgbClr val="CBD8EA"/>
+                      </a:solidFill>
+                      <a:prstDash val="solid"/>
+                      <a:round/>
+                      <a:headEnd type="none" w="med" len="med"/>
+                      <a:tailEnd type="none" w="med" len="med"/>
+                    </a:lnL>
+                    <a:lnR w="9525" cap="flat" cmpd="sng" algn="ctr">
+                      <a:solidFill>
+                        <a:srgbClr val="CBD8EA"/>
+                      </a:solidFill>
+                      <a:prstDash val="solid"/>
+                      <a:round/>
+                      <a:headEnd type="none" w="med" len="med"/>
+                      <a:tailEnd type="none" w="med" len="med"/>
+                    </a:lnR>
+                    <a:lnT w="9525" cap="flat" cmpd="sng" algn="ctr">
+                      <a:solidFill>
+                        <a:srgbClr val="CBD8EA"/>
+                      </a:solidFill>
+                      <a:prstDash val="solid"/>
+                      <a:round/>
+                      <a:headEnd type="none" w="med" len="med"/>
+                      <a:tailEnd type="none" w="med" len="med"/>
+                    </a:lnT>
+                    <a:lnB w="9525" cap="flat" cmpd="sng" algn="ctr">
+                      <a:solidFill>
+                        <a:srgbClr val="CBD8EA"/>
+                      </a:solidFill>
+                      <a:prstDash val="solid"/>
+                      <a:round/>
+                      <a:headEnd type="none" w="med" len="med"/>
+                      <a:tailEnd type="none" w="med" len="med"/>
+                    </a:lnB>
+                  </a:tcPr>
+                </a:tc>
+                <a:tc>
+                  <a:txBody>
+                    <a:bodyPr/>
+                    <a:lstStyle/>
+                    <a:p>
+                      <a:pPr indent="0" marL="0">
+                        <a:buNone/>
+                      </a:pPr>
+                      <a:r>
+                        <a:rPr lang="en-US" sz="1200" dirty="0">
+                          <a:solidFill>
+                            <a:srgbClr val="14183A"/>
+                          </a:solidFill>
+                          <a:latin typeface="Calibri" pitchFamily="34" charset="0"/>
+                          <a:ea typeface="Calibri" pitchFamily="34" charset="-122"/>
+                          <a:cs typeface="Calibri" pitchFamily="34" charset="-120"/>
+                        </a:rPr>
+                        <a:t>$0</a:t>
+                      </a:r>
+                      <a:endParaRPr lang="en-US" sz="1200" dirty="0">
+                        <a:latin typeface="Calibri" charset="0"/>
+                        <a:ea typeface="Calibri" charset="0"/>
+                        <a:cs typeface="Calibri" charset="0"/>
+                      </a:endParaRPr>
+                    </a:p>
+                  </a:txBody>
+                  <a:tcPr marL="36576" marR="36576" marT="36576" marB="36576" anchor="ctr">
+                    <a:lnL w="9525" cap="flat" cmpd="sng" algn="ctr">
+                      <a:solidFill>
+                        <a:srgbClr val="CBD8EA"/>
+                      </a:solidFill>
+                      <a:prstDash val="solid"/>
+                      <a:round/>
+                      <a:headEnd type="none" w="med" len="med"/>
+                      <a:tailEnd type="none" w="med" len="med"/>
+                    </a:lnL>
+                    <a:lnR w="9525" cap="flat" cmpd="sng" algn="ctr">
+                      <a:solidFill>
+                        <a:srgbClr val="CBD8EA"/>
+                      </a:solidFill>
+                      <a:prstDash val="solid"/>
+                      <a:round/>
+                      <a:headEnd type="none" w="med" len="med"/>
+                      <a:tailEnd type="none" w="med" len="med"/>
+                    </a:lnR>
+                    <a:lnT w="9525" cap="flat" cmpd="sng" algn="ctr">
+                      <a:solidFill>
+                        <a:srgbClr val="CBD8EA"/>
+                      </a:solidFill>
+                      <a:prstDash val="solid"/>
+                      <a:round/>
+                      <a:headEnd type="none" w="med" len="med"/>
+                      <a:tailEnd type="none" w="med" len="med"/>
+                    </a:lnT>
+                    <a:lnB w="9525" cap="flat" cmpd="sng" algn="ctr">
+                      <a:solidFill>
+                        <a:srgbClr val="CBD8EA"/>
+                      </a:solidFill>
+                      <a:prstDash val="solid"/>
+                      <a:round/>
+                      <a:headEnd type="none" w="med" len="med"/>
+                      <a:tailEnd type="none" w="med" len="med"/>
+                    </a:lnB>
+                  </a:tcPr>
+                </a:tc>
+                <a:tc>
+                  <a:txBody>
+                    <a:bodyPr/>
+                    <a:lstStyle/>
+                    <a:p>
+                      <a:pPr indent="0" marL="0">
+                        <a:buNone/>
+                      </a:pPr>
+                      <a:r>
+                        <a:rPr lang="en-US" sz="1200" dirty="0">
+                          <a:solidFill>
+                            <a:srgbClr val="14183A"/>
+                          </a:solidFill>
+                          <a:latin typeface="Calibri" pitchFamily="34" charset="0"/>
+                          <a:ea typeface="Calibri" pitchFamily="34" charset="-122"/>
+                          <a:cs typeface="Calibri" pitchFamily="34" charset="-120"/>
+                        </a:rPr>
+                        <a:t>$0</a:t>
+                      </a:r>
+                      <a:endParaRPr lang="en-US" sz="1200" dirty="0">
+                        <a:latin typeface="Calibri" charset="0"/>
+                        <a:ea typeface="Calibri" charset="0"/>
+                        <a:cs typeface="Calibri" charset="0"/>
+                      </a:endParaRPr>
+                    </a:p>
+                  </a:txBody>
+                  <a:tcPr marL="36576" marR="36576" marT="36576" marB="36576" anchor="ctr">
+                    <a:lnL w="9525" cap="flat" cmpd="sng" algn="ctr">
+                      <a:solidFill>
+                        <a:srgbClr val="CBD8EA"/>
+                      </a:solidFill>
+                      <a:prstDash val="solid"/>
+                      <a:round/>
+                      <a:headEnd type="none" w="med" len="med"/>
+                      <a:tailEnd type="none" w="med" len="med"/>
+                    </a:lnL>
+                    <a:lnR w="9525" cap="flat" cmpd="sng" algn="ctr">
+                      <a:solidFill>
+                        <a:srgbClr val="CBD8EA"/>
+                      </a:solidFill>
+                      <a:prstDash val="solid"/>
+                      <a:round/>
+                      <a:headEnd type="none" w="med" len="med"/>
+                      <a:tailEnd type="none" w="med" len="med"/>
+                    </a:lnR>
+                    <a:lnT w="9525" cap="flat" cmpd="sng" algn="ctr">
+                      <a:solidFill>
+                        <a:srgbClr val="CBD8EA"/>
+                      </a:solidFill>
+                      <a:prstDash val="solid"/>
+                      <a:round/>
+                      <a:headEnd type="none" w="med" len="med"/>
+                      <a:tailEnd type="none" w="med" len="med"/>
+                    </a:lnT>
+                    <a:lnB w="9525" cap="flat" cmpd="sng" algn="ctr">
+                      <a:solidFill>
+                        <a:srgbClr val="CBD8EA"/>
+                      </a:solidFill>
+                      <a:prstDash val="solid"/>
+                      <a:round/>
+                      <a:headEnd type="none" w="med" len="med"/>
+                      <a:tailEnd type="none" w="med" len="med"/>
+                    </a:lnB>
+                  </a:tcPr>
+                </a:tc>
+              </a:tr>
+              <a:tr h="365760">
+                <a:tc>
+                  <a:txBody>
+                    <a:bodyPr/>
+                    <a:lstStyle/>
+                    <a:p>
+                      <a:pPr indent="0" marL="0">
+                        <a:buNone/>
+                      </a:pPr>
+                      <a:r>
+                        <a:rPr lang="en-US" sz="1200" dirty="0">
+                          <a:solidFill>
+                            <a:srgbClr val="14183A"/>
+                          </a:solidFill>
+                          <a:latin typeface="Calibri" pitchFamily="34" charset="0"/>
+                          <a:ea typeface="Calibri" pitchFamily="34" charset="-122"/>
+                          <a:cs typeface="Calibri" pitchFamily="34" charset="-120"/>
+                        </a:rPr>
+                        <a:t>Dominio</a:t>
+                      </a:r>
+                      <a:endParaRPr lang="en-US" sz="1200" dirty="0">
+                        <a:latin typeface="Calibri" charset="0"/>
+                        <a:ea typeface="Calibri" charset="0"/>
+                        <a:cs typeface="Calibri" charset="0"/>
+                      </a:endParaRPr>
+                    </a:p>
+                  </a:txBody>
+                  <a:tcPr marL="36576" marR="36576" marT="36576" marB="36576" anchor="ctr">
+                    <a:lnL w="9525" cap="flat" cmpd="sng" algn="ctr">
+                      <a:solidFill>
+                        <a:srgbClr val="CBD8EA"/>
+                      </a:solidFill>
+                      <a:prstDash val="solid"/>
+                      <a:round/>
+                      <a:headEnd type="none" w="med" len="med"/>
+                      <a:tailEnd type="none" w="med" len="med"/>
+                    </a:lnL>
+                    <a:lnR w="9525" cap="flat" cmpd="sng" algn="ctr">
+                      <a:solidFill>
+                        <a:srgbClr val="CBD8EA"/>
+                      </a:solidFill>
+                      <a:prstDash val="solid"/>
+                      <a:round/>
+                      <a:headEnd type="none" w="med" len="med"/>
+                      <a:tailEnd type="none" w="med" len="med"/>
+                    </a:lnR>
+                    <a:lnT w="9525" cap="flat" cmpd="sng" algn="ctr">
+                      <a:solidFill>
+                        <a:srgbClr val="CBD8EA"/>
+                      </a:solidFill>
+                      <a:prstDash val="solid"/>
+                      <a:round/>
+                      <a:headEnd type="none" w="med" len="med"/>
+                      <a:tailEnd type="none" w="med" len="med"/>
+                    </a:lnT>
+                    <a:lnB w="9525" cap="flat" cmpd="sng" algn="ctr">
+                      <a:solidFill>
+                        <a:srgbClr val="CBD8EA"/>
+                      </a:solidFill>
+                      <a:prstDash val="solid"/>
+                      <a:round/>
+                      <a:headEnd type="none" w="med" len="med"/>
+                      <a:tailEnd type="none" w="med" len="med"/>
+                    </a:lnB>
+                  </a:tcPr>
+                </a:tc>
+                <a:tc>
+                  <a:txBody>
+                    <a:bodyPr/>
+                    <a:lstStyle/>
+                    <a:p>
+                      <a:pPr indent="0" marL="0">
+                        <a:buNone/>
+                      </a:pPr>
+                      <a:r>
+                        <a:rPr lang="en-US" sz="1200" dirty="0">
+                          <a:solidFill>
+                            <a:srgbClr val="14183A"/>
+                          </a:solidFill>
+                          <a:latin typeface="Calibri" pitchFamily="34" charset="0"/>
+                          <a:ea typeface="Calibri" pitchFamily="34" charset="-122"/>
+                          <a:cs typeface="Calibri" pitchFamily="34" charset="-120"/>
+                        </a:rPr>
+                        <a:t>La dirección web del sistema</a:t>
+                      </a:r>
+                      <a:endParaRPr lang="en-US" sz="1200" dirty="0">
+                        <a:latin typeface="Calibri" charset="0"/>
+                        <a:ea typeface="Calibri" charset="0"/>
+                        <a:cs typeface="Calibri" charset="0"/>
+                      </a:endParaRPr>
+                    </a:p>
+                  </a:txBody>
+                  <a:tcPr marL="36576" marR="36576" marT="36576" marB="36576" anchor="ctr">
+                    <a:lnL w="9525" cap="flat" cmpd="sng" algn="ctr">
+                      <a:solidFill>
+                        <a:srgbClr val="CBD8EA"/>
+                      </a:solidFill>
+                      <a:prstDash val="solid"/>
+                      <a:round/>
+                      <a:headEnd type="none" w="med" len="med"/>
+                      <a:tailEnd type="none" w="med" len="med"/>
+                    </a:lnL>
+                    <a:lnR w="9525" cap="flat" cmpd="sng" algn="ctr">
+                      <a:solidFill>
+                        <a:srgbClr val="CBD8EA"/>
+                      </a:solidFill>
+                      <a:prstDash val="solid"/>
+                      <a:round/>
+                      <a:headEnd type="none" w="med" len="med"/>
+                      <a:tailEnd type="none" w="med" len="med"/>
+                    </a:lnR>
+                    <a:lnT w="9525" cap="flat" cmpd="sng" algn="ctr">
+                      <a:solidFill>
+                        <a:srgbClr val="CBD8EA"/>
+                      </a:solidFill>
+                      <a:prstDash val="solid"/>
+                      <a:round/>
+                      <a:headEnd type="none" w="med" len="med"/>
+                      <a:tailEnd type="none" w="med" len="med"/>
+                    </a:lnT>
+                    <a:lnB w="9525" cap="flat" cmpd="sng" algn="ctr">
+                      <a:solidFill>
+                        <a:srgbClr val="CBD8EA"/>
+                      </a:solidFill>
+                      <a:prstDash val="solid"/>
+                      <a:round/>
+                      <a:headEnd type="none" w="med" len="med"/>
+                      <a:tailEnd type="none" w="med" len="med"/>
+                    </a:lnB>
+                  </a:tcPr>
+                </a:tc>
+                <a:tc>
+                  <a:txBody>
+                    <a:bodyPr/>
+                    <a:lstStyle/>
+                    <a:p>
+                      <a:pPr indent="0" marL="0">
+                        <a:buNone/>
+                      </a:pPr>
+                      <a:r>
+                        <a:rPr lang="en-US" sz="1200" dirty="0">
+                          <a:solidFill>
+                            <a:srgbClr val="14183A"/>
+                          </a:solidFill>
+                          <a:latin typeface="Calibri" pitchFamily="34" charset="0"/>
+                          <a:ea typeface="Calibri" pitchFamily="34" charset="-122"/>
+                          <a:cs typeface="Calibri" pitchFamily="34" charset="-120"/>
+                        </a:rPr>
+                        <a:t>≈ $1</a:t>
+                      </a:r>
+                      <a:endParaRPr lang="en-US" sz="1200" dirty="0">
+                        <a:latin typeface="Calibri" charset="0"/>
+                        <a:ea typeface="Calibri" charset="0"/>
+                        <a:cs typeface="Calibri" charset="0"/>
+                      </a:endParaRPr>
+                    </a:p>
+                  </a:txBody>
+                  <a:tcPr marL="36576" marR="36576" marT="36576" marB="36576" anchor="ctr">
+                    <a:lnL w="9525" cap="flat" cmpd="sng" algn="ctr">
+                      <a:solidFill>
+                        <a:srgbClr val="CBD8EA"/>
+                      </a:solidFill>
+                      <a:prstDash val="solid"/>
+                      <a:round/>
+                      <a:headEnd type="none" w="med" len="med"/>
+                      <a:tailEnd type="none" w="med" len="med"/>
+                    </a:lnL>
+                    <a:lnR w="9525" cap="flat" cmpd="sng" algn="ctr">
+                      <a:solidFill>
+                        <a:srgbClr val="CBD8EA"/>
+                      </a:solidFill>
+                      <a:prstDash val="solid"/>
+                      <a:round/>
+                      <a:headEnd type="none" w="med" len="med"/>
+                      <a:tailEnd type="none" w="med" len="med"/>
+                    </a:lnR>
+                    <a:lnT w="9525" cap="flat" cmpd="sng" algn="ctr">
+                      <a:solidFill>
+                        <a:srgbClr val="CBD8EA"/>
+                      </a:solidFill>
+                      <a:prstDash val="solid"/>
+                      <a:round/>
+                      <a:headEnd type="none" w="med" len="med"/>
+                      <a:tailEnd type="none" w="med" len="med"/>
+                    </a:lnT>
+                    <a:lnB w="9525" cap="flat" cmpd="sng" algn="ctr">
+                      <a:solidFill>
+                        <a:srgbClr val="CBD8EA"/>
+                      </a:solidFill>
+                      <a:prstDash val="solid"/>
+                      <a:round/>
+                      <a:headEnd type="none" w="med" len="med"/>
+                      <a:tailEnd type="none" w="med" len="med"/>
+                    </a:lnB>
+                  </a:tcPr>
+                </a:tc>
+                <a:tc>
+                  <a:txBody>
+                    <a:bodyPr/>
+                    <a:lstStyle/>
+                    <a:p>
+                      <a:pPr indent="0" marL="0">
+                        <a:buNone/>
+                      </a:pPr>
+                      <a:r>
+                        <a:rPr lang="en-US" sz="1200" dirty="0">
+                          <a:solidFill>
+                            <a:srgbClr val="14183A"/>
+                          </a:solidFill>
+                          <a:latin typeface="Calibri" pitchFamily="34" charset="0"/>
+                          <a:ea typeface="Calibri" pitchFamily="34" charset="-122"/>
+                          <a:cs typeface="Calibri" pitchFamily="34" charset="-120"/>
+                        </a:rPr>
+                        <a:t>≈ $12</a:t>
+                      </a:r>
+                      <a:endParaRPr lang="en-US" sz="1200" dirty="0">
+                        <a:latin typeface="Calibri" charset="0"/>
+                        <a:ea typeface="Calibri" charset="0"/>
+                        <a:cs typeface="Calibri" charset="0"/>
+                      </a:endParaRPr>
+                    </a:p>
+                  </a:txBody>
+                  <a:tcPr marL="36576" marR="36576" marT="36576" marB="36576" anchor="ctr">
+                    <a:lnL w="9525" cap="flat" cmpd="sng" algn="ctr">
+                      <a:solidFill>
+                        <a:srgbClr val="CBD8EA"/>
+                      </a:solidFill>
+                      <a:prstDash val="solid"/>
+                      <a:round/>
+                      <a:headEnd type="none" w="med" len="med"/>
+                      <a:tailEnd type="none" w="med" len="med"/>
+                    </a:lnL>
+                    <a:lnR w="9525" cap="flat" cmpd="sng" algn="ctr">
+                      <a:solidFill>
+                        <a:srgbClr val="CBD8EA"/>
+                      </a:solidFill>
+                      <a:prstDash val="solid"/>
+                      <a:round/>
+                      <a:headEnd type="none" w="med" len="med"/>
+                      <a:tailEnd type="none" w="med" len="med"/>
+                    </a:lnR>
+                    <a:lnT w="9525" cap="flat" cmpd="sng" algn="ctr">
+                      <a:solidFill>
+                        <a:srgbClr val="CBD8EA"/>
+                      </a:solidFill>
+                      <a:prstDash val="solid"/>
+                      <a:round/>
+                      <a:headEnd type="none" w="med" len="med"/>
+                      <a:tailEnd type="none" w="med" len="med"/>
+                    </a:lnT>
+                    <a:lnB w="9525" cap="flat" cmpd="sng" algn="ctr">
+                      <a:solidFill>
+                        <a:srgbClr val="CBD8EA"/>
+                      </a:solidFill>
+                      <a:prstDash val="solid"/>
+                      <a:round/>
+                      <a:headEnd type="none" w="med" len="med"/>
+                      <a:tailEnd type="none" w="med" len="med"/>
+                    </a:lnB>
+                  </a:tcPr>
+                </a:tc>
+              </a:tr>
+              <a:tr h="365760">
+                <a:tc>
+                  <a:txBody>
+                    <a:bodyPr/>
+                    <a:lstStyle/>
+                    <a:p>
+                      <a:pPr indent="0" marL="0">
+                        <a:buNone/>
+                      </a:pPr>
+                      <a:r>
+                        <a:rPr lang="en-US" sz="1200" b="1" dirty="0">
+                          <a:solidFill>
+                            <a:srgbClr val="14183A"/>
+                          </a:solidFill>
+                          <a:latin typeface="Calibri" pitchFamily="34" charset="0"/>
+                          <a:ea typeface="Calibri" pitchFamily="34" charset="-122"/>
+                          <a:cs typeface="Calibri" pitchFamily="34" charset="-120"/>
+                        </a:rPr>
+                        <a:t>Total al arrancar</a:t>
+                      </a:r>
+                      <a:endParaRPr lang="en-US" sz="1200" dirty="0">
+                        <a:latin typeface="Calibri" charset="0"/>
+                        <a:ea typeface="Calibri" charset="0"/>
+                        <a:cs typeface="Calibri" charset="0"/>
+                      </a:endParaRPr>
+                    </a:p>
+                  </a:txBody>
+                  <a:tcPr marL="36576" marR="36576" marT="36576" marB="36576" anchor="ctr">
+                    <a:lnL w="9525" cap="flat" cmpd="sng" algn="ctr">
+                      <a:solidFill>
+                        <a:srgbClr val="CBD8EA"/>
+                      </a:solidFill>
+                      <a:prstDash val="solid"/>
+                      <a:round/>
+                      <a:headEnd type="none" w="med" len="med"/>
+                      <a:tailEnd type="none" w="med" len="med"/>
+                    </a:lnL>
+                    <a:lnR w="9525" cap="flat" cmpd="sng" algn="ctr">
+                      <a:solidFill>
+                        <a:srgbClr val="CBD8EA"/>
+                      </a:solidFill>
+                      <a:prstDash val="solid"/>
+                      <a:round/>
+                      <a:headEnd type="none" w="med" len="med"/>
+                      <a:tailEnd type="none" w="med" len="med"/>
+                    </a:lnR>
+                    <a:lnT w="9525" cap="flat" cmpd="sng" algn="ctr">
+                      <a:solidFill>
+                        <a:srgbClr val="CBD8EA"/>
+                      </a:solidFill>
+                      <a:prstDash val="solid"/>
+                      <a:round/>
+                      <a:headEnd type="none" w="med" len="med"/>
+                      <a:tailEnd type="none" w="med" len="med"/>
+                    </a:lnT>
+                    <a:lnB w="9525" cap="flat" cmpd="sng" algn="ctr">
+                      <a:solidFill>
+                        <a:srgbClr val="CBD8EA"/>
+                      </a:solidFill>
+                      <a:prstDash val="solid"/>
+                      <a:round/>
+                      <a:headEnd type="none" w="med" len="med"/>
+                      <a:tailEnd type="none" w="med" len="med"/>
+                    </a:lnB>
+                  </a:tcPr>
+                </a:tc>
+                <a:tc>
+                  <a:txBody>
+                    <a:bodyPr/>
+                    <a:lstStyle/>
+                    <a:p>
+                      <a:pPr indent="0" marL="0">
+                        <a:buNone/>
+                      </a:pPr>
+                      <a:endParaRPr lang="en-US" sz="1200" dirty="0">
+                        <a:latin typeface="Calibri" charset="0"/>
+                        <a:ea typeface="Calibri" charset="0"/>
+                        <a:cs typeface="Calibri" charset="0"/>
+                      </a:endParaRPr>
+                    </a:p>
+                  </a:txBody>
+                  <a:tcPr marL="36576" marR="36576" marT="36576" marB="36576" anchor="ctr">
+                    <a:lnL w="9525" cap="flat" cmpd="sng" algn="ctr">
+                      <a:solidFill>
+                        <a:srgbClr val="CBD8EA"/>
+                      </a:solidFill>
+                      <a:prstDash val="solid"/>
+                      <a:round/>
+                      <a:headEnd type="none" w="med" len="med"/>
+                      <a:tailEnd type="none" w="med" len="med"/>
+                    </a:lnL>
+                    <a:lnR w="9525" cap="flat" cmpd="sng" algn="ctr">
+                      <a:solidFill>
+                        <a:srgbClr val="CBD8EA"/>
+                      </a:solidFill>
+                      <a:prstDash val="solid"/>
+                      <a:round/>
+                      <a:headEnd type="none" w="med" len="med"/>
+                      <a:tailEnd type="none" w="med" len="med"/>
+                    </a:lnR>
+                    <a:lnT w="9525" cap="flat" cmpd="sng" algn="ctr">
+                      <a:solidFill>
+                        <a:srgbClr val="CBD8EA"/>
+                      </a:solidFill>
+                      <a:prstDash val="solid"/>
+                      <a:round/>
+                      <a:headEnd type="none" w="med" len="med"/>
+                      <a:tailEnd type="none" w="med" len="med"/>
+                    </a:lnT>
+                    <a:lnB w="9525" cap="flat" cmpd="sng" algn="ctr">
+                      <a:solidFill>
+                        <a:srgbClr val="CBD8EA"/>
+                      </a:solidFill>
+                      <a:prstDash val="solid"/>
+                      <a:round/>
+                      <a:headEnd type="none" w="med" len="med"/>
+                      <a:tailEnd type="none" w="med" len="med"/>
+                    </a:lnB>
+                  </a:tcPr>
+                </a:tc>
+                <a:tc>
+                  <a:txBody>
+                    <a:bodyPr/>
+                    <a:lstStyle/>
+                    <a:p>
+                      <a:pPr indent="0" marL="0">
+                        <a:buNone/>
+                      </a:pPr>
+                      <a:r>
+                        <a:rPr lang="en-US" sz="1200" b="1" dirty="0">
+                          <a:solidFill>
+                            <a:srgbClr val="14183A"/>
+                          </a:solidFill>
+                          <a:latin typeface="Calibri" pitchFamily="34" charset="0"/>
+                          <a:ea typeface="Calibri" pitchFamily="34" charset="-122"/>
+                          <a:cs typeface="Calibri" pitchFamily="34" charset="-120"/>
+                        </a:rPr>
+                        <a:t>$21</a:t>
+                      </a:r>
+                      <a:endParaRPr lang="en-US" sz="1200" dirty="0">
+                        <a:latin typeface="Calibri" charset="0"/>
+                        <a:ea typeface="Calibri" charset="0"/>
+                        <a:cs typeface="Calibri" charset="0"/>
+                      </a:endParaRPr>
+                    </a:p>
+                  </a:txBody>
+                  <a:tcPr marL="36576" marR="36576" marT="36576" marB="36576" anchor="ctr">
+                    <a:lnL w="9525" cap="flat" cmpd="sng" algn="ctr">
+                      <a:solidFill>
+                        <a:srgbClr val="CBD8EA"/>
+                      </a:solidFill>
+                      <a:prstDash val="solid"/>
+                      <a:round/>
+                      <a:headEnd type="none" w="med" len="med"/>
+                      <a:tailEnd type="none" w="med" len="med"/>
+                    </a:lnL>
+                    <a:lnR w="9525" cap="flat" cmpd="sng" algn="ctr">
+                      <a:solidFill>
+                        <a:srgbClr val="CBD8EA"/>
+                      </a:solidFill>
+                      <a:prstDash val="solid"/>
+                      <a:round/>
+                      <a:headEnd type="none" w="med" len="med"/>
+                      <a:tailEnd type="none" w="med" len="med"/>
+                    </a:lnR>
+                    <a:lnT w="9525" cap="flat" cmpd="sng" algn="ctr">
+                      <a:solidFill>
+                        <a:srgbClr val="CBD8EA"/>
+                      </a:solidFill>
+                      <a:prstDash val="solid"/>
+                      <a:round/>
+                      <a:headEnd type="none" w="med" len="med"/>
+                      <a:tailEnd type="none" w="med" len="med"/>
+                    </a:lnT>
+                    <a:lnB w="9525" cap="flat" cmpd="sng" algn="ctr">
+                      <a:solidFill>
+                        <a:srgbClr val="CBD8EA"/>
+                      </a:solidFill>
+                      <a:prstDash val="solid"/>
+                      <a:round/>
+                      <a:headEnd type="none" w="med" len="med"/>
+                      <a:tailEnd type="none" w="med" len="med"/>
+                    </a:lnB>
+                  </a:tcPr>
+                </a:tc>
+                <a:tc>
+                  <a:txBody>
+                    <a:bodyPr/>
+                    <a:lstStyle/>
+                    <a:p>
+                      <a:pPr indent="0" marL="0">
+                        <a:buNone/>
+                      </a:pPr>
+                      <a:r>
+                        <a:rPr lang="en-US" sz="1200" b="1" dirty="0">
+                          <a:solidFill>
+                            <a:srgbClr val="14183A"/>
+                          </a:solidFill>
+                          <a:latin typeface="Calibri" pitchFamily="34" charset="0"/>
+                          <a:ea typeface="Calibri" pitchFamily="34" charset="-122"/>
+                          <a:cs typeface="Calibri" pitchFamily="34" charset="-120"/>
+                        </a:rPr>
+                        <a:t>$252</a:t>
+                      </a:r>
+                      <a:endParaRPr lang="en-US" sz="1200" dirty="0">
+                        <a:latin typeface="Calibri" charset="0"/>
+                        <a:ea typeface="Calibri" charset="0"/>
+                        <a:cs typeface="Calibri" charset="0"/>
+                      </a:endParaRPr>
+                    </a:p>
+                  </a:txBody>
+                  <a:tcPr marL="36576" marR="36576" marT="36576" marB="36576" anchor="ctr">
+                    <a:lnL w="9525" cap="flat" cmpd="sng" algn="ctr">
+                      <a:solidFill>
+                        <a:srgbClr val="CBD8EA"/>
+                      </a:solidFill>
+                      <a:prstDash val="solid"/>
+                      <a:round/>
+                      <a:headEnd type="none" w="med" len="med"/>
+                      <a:tailEnd type="none" w="med" len="med"/>
+                    </a:lnL>
+                    <a:lnR w="9525" cap="flat" cmpd="sng" algn="ctr">
+                      <a:solidFill>
+                        <a:srgbClr val="CBD8EA"/>
+                      </a:solidFill>
+                      <a:prstDash val="solid"/>
+                      <a:round/>
+                      <a:headEnd type="none" w="med" len="med"/>
+                      <a:tailEnd type="none" w="med" len="med"/>
+                    </a:lnR>
+                    <a:lnT w="9525" cap="flat" cmpd="sng" algn="ctr">
+                      <a:solidFill>
+                        <a:srgbClr val="CBD8EA"/>
+                      </a:solidFill>
+                      <a:prstDash val="solid"/>
+                      <a:round/>
+                      <a:headEnd type="none" w="med" len="med"/>
+                      <a:tailEnd type="none" w="med" len="med"/>
+                    </a:lnT>
+                    <a:lnB w="9525" cap="flat" cmpd="sng" algn="ctr">
+                      <a:solidFill>
+                        <a:srgbClr val="CBD8EA"/>
+                      </a:solidFill>
+                      <a:prstDash val="solid"/>
+                      <a:round/>
+                      <a:headEnd type="none" w="med" len="med"/>
+                      <a:tailEnd type="none" w="med" len="med"/>
+                    </a:lnB>
+                  </a:tcPr>
+                </a:tc>
+              </a:tr>
+              <a:tr h="365760">
+                <a:tc>
+                  <a:txBody>
+                    <a:bodyPr/>
+                    <a:lstStyle/>
+                    <a:p>
+                      <a:pPr indent="0" marL="0">
+                        <a:buNone/>
+                      </a:pPr>
+                      <a:r>
+                        <a:rPr lang="en-US" sz="1200" dirty="0">
+                          <a:solidFill>
+                            <a:srgbClr val="14183A"/>
+                          </a:solidFill>
+                          <a:latin typeface="Calibri" pitchFamily="34" charset="0"/>
+                          <a:ea typeface="Calibri" pitchFamily="34" charset="-122"/>
+                          <a:cs typeface="Calibri" pitchFamily="34" charset="-120"/>
+                        </a:rPr>
+                        <a:t>Supabase Pro (cuando crezca)</a:t>
+                      </a:r>
+                      <a:endParaRPr lang="en-US" sz="1200" dirty="0">
+                        <a:latin typeface="Calibri" charset="0"/>
+                        <a:ea typeface="Calibri" charset="0"/>
+                        <a:cs typeface="Calibri" charset="0"/>
+                      </a:endParaRPr>
+                    </a:p>
+                  </a:txBody>
+                  <a:tcPr marL="36576" marR="36576" marT="36576" marB="36576" anchor="ctr">
+                    <a:lnL w="9525" cap="flat" cmpd="sng" algn="ctr">
+                      <a:solidFill>
+                        <a:srgbClr val="CBD8EA"/>
+                      </a:solidFill>
+                      <a:prstDash val="solid"/>
+                      <a:round/>
+                      <a:headEnd type="none" w="med" len="med"/>
+                      <a:tailEnd type="none" w="med" len="med"/>
+                    </a:lnL>
+                    <a:lnR w="9525" cap="flat" cmpd="sng" algn="ctr">
+                      <a:solidFill>
+                        <a:srgbClr val="CBD8EA"/>
+                      </a:solidFill>
+                      <a:prstDash val="solid"/>
+                      <a:round/>
+                      <a:headEnd type="none" w="med" len="med"/>
+                      <a:tailEnd type="none" w="med" len="med"/>
+                    </a:lnR>
+                    <a:lnT w="9525" cap="flat" cmpd="sng" algn="ctr">
+                      <a:solidFill>
+                        <a:srgbClr val="CBD8EA"/>
+                      </a:solidFill>
+                      <a:prstDash val="solid"/>
+                      <a:round/>
+                      <a:headEnd type="none" w="med" len="med"/>
+                      <a:tailEnd type="none" w="med" len="med"/>
+                    </a:lnT>
+                    <a:lnB w="9525" cap="flat" cmpd="sng" algn="ctr">
+                      <a:solidFill>
+                        <a:srgbClr val="CBD8EA"/>
+                      </a:solidFill>
+                      <a:prstDash val="solid"/>
+                      <a:round/>
+                      <a:headEnd type="none" w="med" len="med"/>
+                      <a:tailEnd type="none" w="med" len="med"/>
+                    </a:lnB>
+                  </a:tcPr>
+                </a:tc>
+                <a:tc>
+                  <a:txBody>
+                    <a:bodyPr/>
+                    <a:lstStyle/>
+                    <a:p>
+                      <a:pPr indent="0" marL="0">
+                        <a:buNone/>
+                      </a:pPr>
+                      <a:r>
+                        <a:rPr lang="en-US" sz="1200" dirty="0">
+                          <a:solidFill>
+                            <a:srgbClr val="14183A"/>
+                          </a:solidFill>
+                          <a:latin typeface="Calibri" pitchFamily="34" charset="0"/>
+                          <a:ea typeface="Calibri" pitchFamily="34" charset="-122"/>
+                          <a:cs typeface="Calibri" pitchFamily="34" charset="-120"/>
+                        </a:rPr>
+                        <a:t>Más espacio y respaldo diario</a:t>
+                      </a:r>
+                      <a:endParaRPr lang="en-US" sz="1200" dirty="0">
+                        <a:latin typeface="Calibri" charset="0"/>
+                        <a:ea typeface="Calibri" charset="0"/>
+                        <a:cs typeface="Calibri" charset="0"/>
+                      </a:endParaRPr>
+                    </a:p>
+                  </a:txBody>
+                  <a:tcPr marL="36576" marR="36576" marT="36576" marB="36576" anchor="ctr">
+                    <a:lnL w="9525" cap="flat" cmpd="sng" algn="ctr">
+                      <a:solidFill>
+                        <a:srgbClr val="CBD8EA"/>
+                      </a:solidFill>
+                      <a:prstDash val="solid"/>
+                      <a:round/>
+                      <a:headEnd type="none" w="med" len="med"/>
+                      <a:tailEnd type="none" w="med" len="med"/>
+                    </a:lnL>
+                    <a:lnR w="9525" cap="flat" cmpd="sng" algn="ctr">
+                      <a:solidFill>
+                        <a:srgbClr val="CBD8EA"/>
+                      </a:solidFill>
+                      <a:prstDash val="solid"/>
+                      <a:round/>
+                      <a:headEnd type="none" w="med" len="med"/>
+                      <a:tailEnd type="none" w="med" len="med"/>
+                    </a:lnR>
+                    <a:lnT w="9525" cap="flat" cmpd="sng" algn="ctr">
+                      <a:solidFill>
+                        <a:srgbClr val="CBD8EA"/>
+                      </a:solidFill>
+                      <a:prstDash val="solid"/>
+                      <a:round/>
+                      <a:headEnd type="none" w="med" len="med"/>
+                      <a:tailEnd type="none" w="med" len="med"/>
+                    </a:lnT>
+                    <a:lnB w="9525" cap="flat" cmpd="sng" algn="ctr">
+                      <a:solidFill>
+                        <a:srgbClr val="CBD8EA"/>
+                      </a:solidFill>
+                      <a:prstDash val="solid"/>
+                      <a:round/>
+                      <a:headEnd type="none" w="med" len="med"/>
+                      <a:tailEnd type="none" w="med" len="med"/>
+                    </a:lnB>
+                  </a:tcPr>
+                </a:tc>
+                <a:tc>
+                  <a:txBody>
+                    <a:bodyPr/>
+                    <a:lstStyle/>
+                    <a:p>
+                      <a:pPr indent="0" marL="0">
+                        <a:buNone/>
+                      </a:pPr>
+                      <a:r>
+                        <a:rPr lang="en-US" sz="1200" dirty="0">
+                          <a:solidFill>
+                            <a:srgbClr val="14183A"/>
+                          </a:solidFill>
+                          <a:latin typeface="Calibri" pitchFamily="34" charset="0"/>
+                          <a:ea typeface="Calibri" pitchFamily="34" charset="-122"/>
+                          <a:cs typeface="Calibri" pitchFamily="34" charset="-120"/>
+                        </a:rPr>
+                        <a:t>+ $25</a:t>
+                      </a:r>
+                      <a:endParaRPr lang="en-US" sz="1200" dirty="0">
+                        <a:latin typeface="Calibri" charset="0"/>
+                        <a:ea typeface="Calibri" charset="0"/>
+                        <a:cs typeface="Calibri" charset="0"/>
+                      </a:endParaRPr>
+                    </a:p>
+                  </a:txBody>
+                  <a:tcPr marL="36576" marR="36576" marT="36576" marB="36576" anchor="ctr">
+                    <a:lnL w="9525" cap="flat" cmpd="sng" algn="ctr">
+                      <a:solidFill>
+                        <a:srgbClr val="CBD8EA"/>
+                      </a:solidFill>
+                      <a:prstDash val="solid"/>
+                      <a:round/>
+                      <a:headEnd type="none" w="med" len="med"/>
+                      <a:tailEnd type="none" w="med" len="med"/>
+                    </a:lnL>
+                    <a:lnR w="9525" cap="flat" cmpd="sng" algn="ctr">
+                      <a:solidFill>
+                        <a:srgbClr val="CBD8EA"/>
+                      </a:solidFill>
+                      <a:prstDash val="solid"/>
+                      <a:round/>
+                      <a:headEnd type="none" w="med" len="med"/>
+                      <a:tailEnd type="none" w="med" len="med"/>
+                    </a:lnR>
+                    <a:lnT w="9525" cap="flat" cmpd="sng" algn="ctr">
+                      <a:solidFill>
+                        <a:srgbClr val="CBD8EA"/>
+                      </a:solidFill>
+                      <a:prstDash val="solid"/>
+                      <a:round/>
+                      <a:headEnd type="none" w="med" len="med"/>
+                      <a:tailEnd type="none" w="med" len="med"/>
+                    </a:lnT>
+                    <a:lnB w="9525" cap="flat" cmpd="sng" algn="ctr">
+                      <a:solidFill>
+                        <a:srgbClr val="CBD8EA"/>
+                      </a:solidFill>
+                      <a:prstDash val="solid"/>
+                      <a:round/>
+                      <a:headEnd type="none" w="med" len="med"/>
+                      <a:tailEnd type="none" w="med" len="med"/>
+                    </a:lnB>
+                  </a:tcPr>
+                </a:tc>
+                <a:tc>
+                  <a:txBody>
+                    <a:bodyPr/>
+                    <a:lstStyle/>
+                    <a:p>
+                      <a:pPr indent="0" marL="0">
+                        <a:buNone/>
+                      </a:pPr>
+                      <a:r>
+                        <a:rPr lang="en-US" sz="1200" dirty="0">
+                          <a:solidFill>
+                            <a:srgbClr val="14183A"/>
+                          </a:solidFill>
+                          <a:latin typeface="Calibri" pitchFamily="34" charset="0"/>
+                          <a:ea typeface="Calibri" pitchFamily="34" charset="-122"/>
+                          <a:cs typeface="Calibri" pitchFamily="34" charset="-120"/>
+                        </a:rPr>
+                        <a:t>+ $300</a:t>
+                      </a:r>
+                      <a:endParaRPr lang="en-US" sz="1200" dirty="0">
+                        <a:latin typeface="Calibri" charset="0"/>
+                        <a:ea typeface="Calibri" charset="0"/>
+                        <a:cs typeface="Calibri" charset="0"/>
+                      </a:endParaRPr>
+                    </a:p>
+                  </a:txBody>
+                  <a:tcPr marL="36576" marR="36576" marT="36576" marB="36576" anchor="ctr">
+                    <a:lnL w="9525" cap="flat" cmpd="sng" algn="ctr">
+                      <a:solidFill>
+                        <a:srgbClr val="CBD8EA"/>
+                      </a:solidFill>
+                      <a:prstDash val="solid"/>
+                      <a:round/>
+                      <a:headEnd type="none" w="med" len="med"/>
+                      <a:tailEnd type="none" w="med" len="med"/>
+                    </a:lnL>
+                    <a:lnR w="9525" cap="flat" cmpd="sng" algn="ctr">
+                      <a:solidFill>
+                        <a:srgbClr val="CBD8EA"/>
+                      </a:solidFill>
+                      <a:prstDash val="solid"/>
+                      <a:round/>
+                      <a:headEnd type="none" w="med" len="med"/>
+                      <a:tailEnd type="none" w="med" len="med"/>
+                    </a:lnR>
+                    <a:lnT w="9525" cap="flat" cmpd="sng" algn="ctr">
+                      <a:solidFill>
+                        <a:srgbClr val="CBD8EA"/>
+                      </a:solidFill>
+                      <a:prstDash val="solid"/>
+                      <a:round/>
+                      <a:headEnd type="none" w="med" len="med"/>
+                      <a:tailEnd type="none" w="med" len="med"/>
+                    </a:lnT>
+                    <a:lnB w="9525" cap="flat" cmpd="sng" algn="ctr">
+                      <a:solidFill>
+                        <a:srgbClr val="CBD8EA"/>
+                      </a:solidFill>
+                      <a:prstDash val="solid"/>
+                      <a:round/>
+                      <a:headEnd type="none" w="med" len="med"/>
+                      <a:tailEnd type="none" w="med" len="med"/>
+                    </a:lnB>
+                  </a:tcPr>
+                </a:tc>
+              </a:tr>
+              <a:tr h="365760">
+                <a:tc>
+                  <a:txBody>
+                    <a:bodyPr/>
+                    <a:lstStyle/>
+                    <a:p>
+                      <a:pPr indent="0" marL="0">
+                        <a:buNone/>
+                      </a:pPr>
+                      <a:r>
+                        <a:rPr lang="en-US" sz="1200" b="1" dirty="0">
+                          <a:solidFill>
+                            <a:srgbClr val="14183A"/>
+                          </a:solidFill>
+                          <a:latin typeface="Calibri" pitchFamily="34" charset="0"/>
+                          <a:ea typeface="Calibri" pitchFamily="34" charset="-122"/>
+                          <a:cs typeface="Calibri" pitchFamily="34" charset="-120"/>
+                        </a:rPr>
+                        <a:t>Total con respaldo diario</a:t>
+                      </a:r>
+                      <a:endParaRPr lang="en-US" sz="1200" dirty="0">
+                        <a:latin typeface="Calibri" charset="0"/>
+                        <a:ea typeface="Calibri" charset="0"/>
+                        <a:cs typeface="Calibri" charset="0"/>
+                      </a:endParaRPr>
+                    </a:p>
+                  </a:txBody>
+                  <a:tcPr marL="36576" marR="36576" marT="36576" marB="36576" anchor="ctr">
+                    <a:lnL w="9525" cap="flat" cmpd="sng" algn="ctr">
+                      <a:solidFill>
+                        <a:srgbClr val="CBD8EA"/>
+                      </a:solidFill>
+                      <a:prstDash val="solid"/>
+                      <a:round/>
+                      <a:headEnd type="none" w="med" len="med"/>
+                      <a:tailEnd type="none" w="med" len="med"/>
+                    </a:lnL>
+                    <a:lnR w="9525" cap="flat" cmpd="sng" algn="ctr">
+                      <a:solidFill>
+                        <a:srgbClr val="CBD8EA"/>
+                      </a:solidFill>
+                      <a:prstDash val="solid"/>
+                      <a:round/>
+                      <a:headEnd type="none" w="med" len="med"/>
+                      <a:tailEnd type="none" w="med" len="med"/>
+                    </a:lnR>
+                    <a:lnT w="9525" cap="flat" cmpd="sng" algn="ctr">
+                      <a:solidFill>
+                        <a:srgbClr val="CBD8EA"/>
+                      </a:solidFill>
+                      <a:prstDash val="solid"/>
+                      <a:round/>
+                      <a:headEnd type="none" w="med" len="med"/>
+                      <a:tailEnd type="none" w="med" len="med"/>
+                    </a:lnT>
+                    <a:lnB w="9525" cap="flat" cmpd="sng" algn="ctr">
+                      <a:solidFill>
+                        <a:srgbClr val="CBD8EA"/>
+                      </a:solidFill>
+                      <a:prstDash val="solid"/>
+                      <a:round/>
+                      <a:headEnd type="none" w="med" len="med"/>
+                      <a:tailEnd type="none" w="med" len="med"/>
+                    </a:lnB>
+                  </a:tcPr>
+                </a:tc>
+                <a:tc>
+                  <a:txBody>
+                    <a:bodyPr/>
+                    <a:lstStyle/>
+                    <a:p>
+                      <a:pPr indent="0" marL="0">
+                        <a:buNone/>
+                      </a:pPr>
+                      <a:endParaRPr lang="en-US" sz="1200" dirty="0">
+                        <a:latin typeface="Calibri" charset="0"/>
+                        <a:ea typeface="Calibri" charset="0"/>
+                        <a:cs typeface="Calibri" charset="0"/>
+                      </a:endParaRPr>
+                    </a:p>
+                  </a:txBody>
+                  <a:tcPr marL="36576" marR="36576" marT="36576" marB="36576" anchor="ctr">
+                    <a:lnL w="9525" cap="flat" cmpd="sng" algn="ctr">
+                      <a:solidFill>
+                        <a:srgbClr val="CBD8EA"/>
+                      </a:solidFill>
+                      <a:prstDash val="solid"/>
+                      <a:round/>
+                      <a:headEnd type="none" w="med" len="med"/>
+                      <a:tailEnd type="none" w="med" len="med"/>
+                    </a:lnL>
+                    <a:lnR w="9525" cap="flat" cmpd="sng" algn="ctr">
+                      <a:solidFill>
+                        <a:srgbClr val="CBD8EA"/>
+                      </a:solidFill>
+                      <a:prstDash val="solid"/>
+                      <a:round/>
+                      <a:headEnd type="none" w="med" len="med"/>
+                      <a:tailEnd type="none" w="med" len="med"/>
+                    </a:lnR>
+                    <a:lnT w="9525" cap="flat" cmpd="sng" algn="ctr">
+                      <a:solidFill>
+                        <a:srgbClr val="CBD8EA"/>
+                      </a:solidFill>
+                      <a:prstDash val="solid"/>
+                      <a:round/>
+                      <a:headEnd type="none" w="med" len="med"/>
+                      <a:tailEnd type="none" w="med" len="med"/>
+                    </a:lnT>
+                    <a:lnB w="9525" cap="flat" cmpd="sng" algn="ctr">
+                      <a:solidFill>
+                        <a:srgbClr val="CBD8EA"/>
+                      </a:solidFill>
+                      <a:prstDash val="solid"/>
+                      <a:round/>
+                      <a:headEnd type="none" w="med" len="med"/>
+                      <a:tailEnd type="none" w="med" len="med"/>
+                    </a:lnB>
+                  </a:tcPr>
+                </a:tc>
+                <a:tc>
+                  <a:txBody>
+                    <a:bodyPr/>
+                    <a:lstStyle/>
+                    <a:p>
+                      <a:pPr indent="0" marL="0">
+                        <a:buNone/>
+                      </a:pPr>
+                      <a:r>
+                        <a:rPr lang="en-US" sz="1200" b="1" dirty="0">
+                          <a:solidFill>
+                            <a:srgbClr val="14183A"/>
+                          </a:solidFill>
+                          <a:latin typeface="Calibri" pitchFamily="34" charset="0"/>
+                          <a:ea typeface="Calibri" pitchFamily="34" charset="-122"/>
+                          <a:cs typeface="Calibri" pitchFamily="34" charset="-120"/>
+                        </a:rPr>
+                        <a:t>$46</a:t>
+                      </a:r>
+                      <a:endParaRPr lang="en-US" sz="1200" dirty="0">
+                        <a:latin typeface="Calibri" charset="0"/>
+                        <a:ea typeface="Calibri" charset="0"/>
+                        <a:cs typeface="Calibri" charset="0"/>
+                      </a:endParaRPr>
+                    </a:p>
+                  </a:txBody>
+                  <a:tcPr marL="36576" marR="36576" marT="36576" marB="36576" anchor="ctr">
+                    <a:lnL w="9525" cap="flat" cmpd="sng" algn="ctr">
+                      <a:solidFill>
+                        <a:srgbClr val="CBD8EA"/>
+                      </a:solidFill>
+                      <a:prstDash val="solid"/>
+                      <a:round/>
+                      <a:headEnd type="none" w="med" len="med"/>
+                      <a:tailEnd type="none" w="med" len="med"/>
+                    </a:lnL>
+                    <a:lnR w="9525" cap="flat" cmpd="sng" algn="ctr">
+                      <a:solidFill>
+                        <a:srgbClr val="CBD8EA"/>
+                      </a:solidFill>
+                      <a:prstDash val="solid"/>
+                      <a:round/>
+                      <a:headEnd type="none" w="med" len="med"/>
+                      <a:tailEnd type="none" w="med" len="med"/>
+                    </a:lnR>
+                    <a:lnT w="9525" cap="flat" cmpd="sng" algn="ctr">
+                      <a:solidFill>
+                        <a:srgbClr val="CBD8EA"/>
+                      </a:solidFill>
+                      <a:prstDash val="solid"/>
+                      <a:round/>
+                      <a:headEnd type="none" w="med" len="med"/>
+                      <a:tailEnd type="none" w="med" len="med"/>
+                    </a:lnT>
+                    <a:lnB w="9525" cap="flat" cmpd="sng" algn="ctr">
+                      <a:solidFill>
+                        <a:srgbClr val="CBD8EA"/>
+                      </a:solidFill>
+                      <a:prstDash val="solid"/>
+                      <a:round/>
+                      <a:headEnd type="none" w="med" len="med"/>
+                      <a:tailEnd type="none" w="med" len="med"/>
+                    </a:lnB>
+                  </a:tcPr>
+                </a:tc>
+                <a:tc>
+                  <a:txBody>
+                    <a:bodyPr/>
+                    <a:lstStyle/>
+                    <a:p>
+                      <a:pPr indent="0" marL="0">
+                        <a:buNone/>
+                      </a:pPr>
+                      <a:r>
+                        <a:rPr lang="en-US" sz="1200" b="1" dirty="0">
+                          <a:solidFill>
+                            <a:srgbClr val="14183A"/>
+                          </a:solidFill>
+                          <a:latin typeface="Calibri" pitchFamily="34" charset="0"/>
+                          <a:ea typeface="Calibri" pitchFamily="34" charset="-122"/>
+                          <a:cs typeface="Calibri" pitchFamily="34" charset="-120"/>
+                        </a:rPr>
+                        <a:t>$552</a:t>
+                      </a:r>
+                      <a:endParaRPr lang="en-US" sz="1200" dirty="0">
+                        <a:latin typeface="Calibri" charset="0"/>
+                        <a:ea typeface="Calibri" charset="0"/>
+                        <a:cs typeface="Calibri" charset="0"/>
+                      </a:endParaRPr>
+                    </a:p>
+                  </a:txBody>
+                  <a:tcPr marL="36576" marR="36576" marT="36576" marB="36576" anchor="ctr">
+                    <a:lnL w="9525" cap="flat" cmpd="sng" algn="ctr">
+                      <a:solidFill>
+                        <a:srgbClr val="CBD8EA"/>
+                      </a:solidFill>
+                      <a:prstDash val="solid"/>
+                      <a:round/>
+                      <a:headEnd type="none" w="med" len="med"/>
+                      <a:tailEnd type="none" w="med" len="med"/>
+                    </a:lnL>
+                    <a:lnR w="9525" cap="flat" cmpd="sng" algn="ctr">
+                      <a:solidFill>
+                        <a:srgbClr val="CBD8EA"/>
+                      </a:solidFill>
+                      <a:prstDash val="solid"/>
+                      <a:round/>
+                      <a:headEnd type="none" w="med" len="med"/>
+                      <a:tailEnd type="none" w="med" len="med"/>
+                    </a:lnR>
+                    <a:lnT w="9525" cap="flat" cmpd="sng" algn="ctr">
+                      <a:solidFill>
+                        <a:srgbClr val="CBD8EA"/>
+                      </a:solidFill>
+                      <a:prstDash val="solid"/>
+                      <a:round/>
+                      <a:headEnd type="none" w="med" len="med"/>
+                      <a:tailEnd type="none" w="med" len="med"/>
+                    </a:lnT>
+                    <a:lnB w="9525" cap="flat" cmpd="sng" algn="ctr">
+                      <a:solidFill>
+                        <a:srgbClr val="CBD8EA"/>
+                      </a:solidFill>
+                      <a:prstDash val="solid"/>
+                      <a:round/>
+                      <a:headEnd type="none" w="med" len="med"/>
+                      <a:tailEnd type="none" w="med" len="med"/>
+                    </a:lnB>
+                  </a:tcPr>
+                </a:tc>
+              </a:tr>
+            </a:tbl>
+          </a:graphicData>
+        </a:graphic>
+      </p:graphicFrame>
+      <p:sp>
+        <p:nvSpPr>
+          <p:cNvPr id="4" name="Text 1"/>
           <p:cNvSpPr txBox="1"/>
           <p:nvPr/>
         </p:nvSpPr>
         <p:spPr>
           <a:xfrm>
-            <a:off x="457200" y="1234440"/>
-            <a:ext cx="3931920" cy="457200"/>
+            <a:off x="457200" y="4224528"/>
+            <a:ext cx="5029200" cy="457200"/>
           </a:xfrm>
           <a:prstGeom prst="rect">
             <a:avLst/>
@@ -7988,365 +9844,30 @@
           <a:ln/>
         </p:spPr>
         <p:txBody>
-          <a:bodyPr wrap="square" lIns="0" tIns="0" rIns="0" bIns="0" rtlCol="0" anchor="ctr"/>
+          <a:bodyPr wrap="square" lIns="0" tIns="0" rIns="0" bIns="0" rtlCol="0" anchor="t"/>
           <a:lstStyle/>
           <a:p>
             <a:pPr indent="0" marL="0">
               <a:buNone/>
             </a:pPr>
             <a:r>
-              <a:rPr lang="en-US" sz="1400" dirty="0">
+              <a:rPr lang="en-US" sz="1100" dirty="0">
                 <a:solidFill>
-                  <a:srgbClr val="14183A"/>
+                  <a:srgbClr val="4E5A73"/>
                 </a:solidFill>
                 <a:latin typeface="Calibri" pitchFamily="34" charset="0"/>
                 <a:ea typeface="Calibri" pitchFamily="34" charset="-122"/>
                 <a:cs typeface="Calibri" pitchFamily="34" charset="-120"/>
               </a:rPr>
-              <a:t>Vercel Pro: aloja los tres sistemas</a:t>
+              <a:t>Precios publicados por cada servicio, en dólares; confirmar al contratar. Los mensajes automáticos de WhatsApp (fase 2) los cobra Meta por mensaje y los paga el cliente.</a:t>
             </a:r>
-            <a:endParaRPr lang="en-US" sz="1400" dirty="0"/>
-          </a:p>
-        </p:txBody>
-      </p:sp>
-      <p:sp>
-        <p:nvSpPr>
-          <p:cNvPr id="4" name="Text 2"/>
-          <p:cNvSpPr txBox="1"/>
-          <p:nvPr/>
-        </p:nvSpPr>
-        <p:spPr>
-          <a:xfrm>
-            <a:off x="4389120" y="1234440"/>
-            <a:ext cx="822960" cy="457200"/>
-          </a:xfrm>
-          <a:prstGeom prst="rect">
-            <a:avLst/>
-          </a:prstGeom>
-          <a:noFill/>
-          <a:ln/>
-        </p:spPr>
-        <p:txBody>
-          <a:bodyPr wrap="square" lIns="0" tIns="0" rIns="0" bIns="0" rtlCol="0" anchor="ctr"/>
-          <a:lstStyle/>
-          <a:p>
-            <a:pPr algn="r" indent="0" marL="0">
-              <a:buNone/>
-            </a:pPr>
-            <a:r>
-              <a:rPr lang="en-US" sz="1500" b="1" dirty="0">
-                <a:solidFill>
-                  <a:srgbClr val="0E1752"/>
-                </a:solidFill>
-                <a:latin typeface="Calibri" pitchFamily="34" charset="0"/>
-                <a:ea typeface="Calibri" pitchFamily="34" charset="-122"/>
-                <a:cs typeface="Calibri" pitchFamily="34" charset="-120"/>
-              </a:rPr>
-              <a:t>$20</a:t>
-            </a:r>
-            <a:endParaRPr lang="en-US" sz="1500" dirty="0"/>
-          </a:p>
-        </p:txBody>
-      </p:sp>
-      <p:sp>
-        <p:nvSpPr>
-          <p:cNvPr id="5" name="Text 3"/>
-          <p:cNvSpPr txBox="1"/>
-          <p:nvPr/>
-        </p:nvSpPr>
-        <p:spPr>
-          <a:xfrm>
-            <a:off x="457200" y="1783080"/>
-            <a:ext cx="3931920" cy="457200"/>
-          </a:xfrm>
-          <a:prstGeom prst="rect">
-            <a:avLst/>
-          </a:prstGeom>
-          <a:noFill/>
-          <a:ln/>
-        </p:spPr>
-        <p:txBody>
-          <a:bodyPr wrap="square" lIns="0" tIns="0" rIns="0" bIns="0" rtlCol="0" anchor="ctr"/>
-          <a:lstStyle/>
-          <a:p>
-            <a:pPr indent="0" marL="0">
-              <a:buNone/>
-            </a:pPr>
-            <a:r>
-              <a:rPr lang="en-US" sz="1400" dirty="0">
-                <a:solidFill>
-                  <a:srgbClr val="14183A"/>
-                </a:solidFill>
-                <a:latin typeface="Calibri" pitchFamily="34" charset="0"/>
-                <a:ea typeface="Calibri" pitchFamily="34" charset="-122"/>
-                <a:cs typeface="Calibri" pitchFamily="34" charset="-120"/>
-              </a:rPr>
-              <a:t>Base de datos: plan gratis</a:t>
-            </a:r>
-            <a:endParaRPr lang="en-US" sz="1400" dirty="0"/>
-          </a:p>
-        </p:txBody>
-      </p:sp>
-      <p:sp>
-        <p:nvSpPr>
-          <p:cNvPr id="6" name="Text 4"/>
-          <p:cNvSpPr txBox="1"/>
-          <p:nvPr/>
-        </p:nvSpPr>
-        <p:spPr>
-          <a:xfrm>
-            <a:off x="4389120" y="1783080"/>
-            <a:ext cx="822960" cy="457200"/>
-          </a:xfrm>
-          <a:prstGeom prst="rect">
-            <a:avLst/>
-          </a:prstGeom>
-          <a:noFill/>
-          <a:ln/>
-        </p:spPr>
-        <p:txBody>
-          <a:bodyPr wrap="square" lIns="0" tIns="0" rIns="0" bIns="0" rtlCol="0" anchor="ctr"/>
-          <a:lstStyle/>
-          <a:p>
-            <a:pPr algn="r" indent="0" marL="0">
-              <a:buNone/>
-            </a:pPr>
-            <a:r>
-              <a:rPr lang="en-US" sz="1500" b="1" dirty="0">
-                <a:solidFill>
-                  <a:srgbClr val="0E1752"/>
-                </a:solidFill>
-                <a:latin typeface="Calibri" pitchFamily="34" charset="0"/>
-                <a:ea typeface="Calibri" pitchFamily="34" charset="-122"/>
-                <a:cs typeface="Calibri" pitchFamily="34" charset="-120"/>
-              </a:rPr>
-              <a:t>$0</a:t>
-            </a:r>
-            <a:endParaRPr lang="en-US" sz="1500" dirty="0"/>
-          </a:p>
-        </p:txBody>
-      </p:sp>
-      <p:sp>
-        <p:nvSpPr>
-          <p:cNvPr id="7" name="Text 5"/>
-          <p:cNvSpPr txBox="1"/>
-          <p:nvPr/>
-        </p:nvSpPr>
-        <p:spPr>
-          <a:xfrm>
-            <a:off x="457200" y="2331720"/>
-            <a:ext cx="3931920" cy="457200"/>
-          </a:xfrm>
-          <a:prstGeom prst="rect">
-            <a:avLst/>
-          </a:prstGeom>
-          <a:noFill/>
-          <a:ln/>
-        </p:spPr>
-        <p:txBody>
-          <a:bodyPr wrap="square" lIns="0" tIns="0" rIns="0" bIns="0" rtlCol="0" anchor="ctr"/>
-          <a:lstStyle/>
-          <a:p>
-            <a:pPr indent="0" marL="0">
-              <a:buNone/>
-            </a:pPr>
-            <a:r>
-              <a:rPr lang="en-US" sz="1400" dirty="0">
-                <a:solidFill>
-                  <a:srgbClr val="14183A"/>
-                </a:solidFill>
-                <a:latin typeface="Calibri" pitchFamily="34" charset="0"/>
-                <a:ea typeface="Calibri" pitchFamily="34" charset="-122"/>
-                <a:cs typeface="Calibri" pitchFamily="34" charset="-120"/>
-              </a:rPr>
-              <a:t>Dominio</a:t>
-            </a:r>
-            <a:endParaRPr lang="en-US" sz="1400" dirty="0"/>
-          </a:p>
-        </p:txBody>
-      </p:sp>
-      <p:sp>
-        <p:nvSpPr>
-          <p:cNvPr id="8" name="Text 6"/>
-          <p:cNvSpPr txBox="1"/>
-          <p:nvPr/>
-        </p:nvSpPr>
-        <p:spPr>
-          <a:xfrm>
-            <a:off x="4389120" y="2331720"/>
-            <a:ext cx="822960" cy="457200"/>
-          </a:xfrm>
-          <a:prstGeom prst="rect">
-            <a:avLst/>
-          </a:prstGeom>
-          <a:noFill/>
-          <a:ln/>
-        </p:spPr>
-        <p:txBody>
-          <a:bodyPr wrap="square" lIns="0" tIns="0" rIns="0" bIns="0" rtlCol="0" anchor="ctr"/>
-          <a:lstStyle/>
-          <a:p>
-            <a:pPr algn="r" indent="0" marL="0">
-              <a:buNone/>
-            </a:pPr>
-            <a:r>
-              <a:rPr lang="en-US" sz="1500" b="1" dirty="0">
-                <a:solidFill>
-                  <a:srgbClr val="0E1752"/>
-                </a:solidFill>
-                <a:latin typeface="Calibri" pitchFamily="34" charset="0"/>
-                <a:ea typeface="Calibri" pitchFamily="34" charset="-122"/>
-                <a:cs typeface="Calibri" pitchFamily="34" charset="-120"/>
-              </a:rPr>
-              <a:t>≈ $1</a:t>
-            </a:r>
-            <a:endParaRPr lang="en-US" sz="1500" dirty="0"/>
-          </a:p>
-        </p:txBody>
-      </p:sp>
-      <p:sp>
-        <p:nvSpPr>
-          <p:cNvPr id="9" name="Text 7"/>
-          <p:cNvSpPr txBox="1"/>
-          <p:nvPr/>
-        </p:nvSpPr>
-        <p:spPr>
-          <a:xfrm>
-            <a:off x="457200" y="2880360"/>
-            <a:ext cx="3931920" cy="457200"/>
-          </a:xfrm>
-          <a:prstGeom prst="rect">
-            <a:avLst/>
-          </a:prstGeom>
-          <a:noFill/>
-          <a:ln/>
-        </p:spPr>
-        <p:txBody>
-          <a:bodyPr wrap="square" lIns="0" tIns="0" rIns="0" bIns="0" rtlCol="0" anchor="ctr"/>
-          <a:lstStyle/>
-          <a:p>
-            <a:pPr indent="0" marL="0">
-              <a:buNone/>
-            </a:pPr>
-            <a:r>
-              <a:rPr lang="en-US" sz="1400" dirty="0">
-                <a:solidFill>
-                  <a:srgbClr val="14183A"/>
-                </a:solidFill>
-                <a:latin typeface="Calibri" pitchFamily="34" charset="0"/>
-                <a:ea typeface="Calibri" pitchFamily="34" charset="-122"/>
-                <a:cs typeface="Calibri" pitchFamily="34" charset="-120"/>
-              </a:rPr>
-              <a:t>Base de datos con respaldo diario (plan Pro, más adelante)</a:t>
-            </a:r>
-            <a:endParaRPr lang="en-US" sz="1400" dirty="0"/>
-          </a:p>
-        </p:txBody>
-      </p:sp>
-      <p:sp>
-        <p:nvSpPr>
-          <p:cNvPr id="10" name="Text 8"/>
-          <p:cNvSpPr txBox="1"/>
-          <p:nvPr/>
-        </p:nvSpPr>
-        <p:spPr>
-          <a:xfrm>
-            <a:off x="4389120" y="2880360"/>
-            <a:ext cx="822960" cy="457200"/>
-          </a:xfrm>
-          <a:prstGeom prst="rect">
-            <a:avLst/>
-          </a:prstGeom>
-          <a:noFill/>
-          <a:ln/>
-        </p:spPr>
-        <p:txBody>
-          <a:bodyPr wrap="square" lIns="0" tIns="0" rIns="0" bIns="0" rtlCol="0" anchor="ctr"/>
-          <a:lstStyle/>
-          <a:p>
-            <a:pPr algn="r" indent="0" marL="0">
-              <a:buNone/>
-            </a:pPr>
-            <a:r>
-              <a:rPr lang="en-US" sz="1500" b="1" dirty="0">
-                <a:solidFill>
-                  <a:srgbClr val="0E1752"/>
-                </a:solidFill>
-                <a:latin typeface="Calibri" pitchFamily="34" charset="0"/>
-                <a:ea typeface="Calibri" pitchFamily="34" charset="-122"/>
-                <a:cs typeface="Calibri" pitchFamily="34" charset="-120"/>
-              </a:rPr>
-              <a:t>+ $25</a:t>
-            </a:r>
-            <a:endParaRPr lang="en-US" sz="1500" dirty="0"/>
-          </a:p>
-        </p:txBody>
-      </p:sp>
-      <p:sp>
-        <p:nvSpPr>
-          <p:cNvPr id="11" name="Shape 9"/>
-          <p:cNvSpPr/>
-          <p:nvPr/>
-        </p:nvSpPr>
-        <p:spPr>
-          <a:xfrm>
-            <a:off x="457200" y="3474720"/>
-            <a:ext cx="4754880" cy="0"/>
-          </a:xfrm>
-          <a:prstGeom prst="line">
-            <a:avLst/>
-          </a:prstGeom>
-          <a:noFill/>
-          <a:ln w="9525">
-            <a:solidFill>
-              <a:srgbClr val="8A93A8"/>
-            </a:solidFill>
-            <a:prstDash val="solid"/>
-          </a:ln>
-        </p:spPr>
-      </p:sp>
-      <p:sp>
-        <p:nvSpPr>
-          <p:cNvPr id="12" name="Text 10"/>
-          <p:cNvSpPr txBox="1"/>
-          <p:nvPr/>
-        </p:nvSpPr>
-        <p:spPr>
-          <a:xfrm>
-            <a:off x="457200" y="3566160"/>
-            <a:ext cx="4754880" cy="457200"/>
-          </a:xfrm>
-          <a:prstGeom prst="rect">
-            <a:avLst/>
-          </a:prstGeom>
-          <a:noFill/>
-          <a:ln/>
-        </p:spPr>
-        <p:txBody>
-          <a:bodyPr wrap="square" lIns="0" tIns="0" rIns="0" bIns="0" rtlCol="0" anchor="ctr"/>
-          <a:lstStyle/>
-          <a:p>
-            <a:pPr indent="0" marL="0">
-              <a:buNone/>
-            </a:pPr>
-            <a:r>
-              <a:rPr lang="en-US" sz="1500" b="1" dirty="0">
-                <a:solidFill>
-                  <a:srgbClr val="0E1752"/>
-                </a:solidFill>
-                <a:latin typeface="Calibri" pitchFamily="34" charset="0"/>
-                <a:ea typeface="Calibri" pitchFamily="34" charset="-122"/>
-                <a:cs typeface="Calibri" pitchFamily="34" charset="-120"/>
-              </a:rPr>
-              <a:t>En efectivo: $21 al mes; $46 con respaldo diario</a:t>
-            </a:r>
-            <a:endParaRPr lang="en-US" sz="1500" dirty="0"/>
-          </a:p>
-        </p:txBody>
-      </p:sp>
-      <p:sp>
-        <p:nvSpPr>
-          <p:cNvPr id="13" name="Shape 11"/>
+            <a:endParaRPr lang="en-US" sz="1100" dirty="0"/>
+          </a:p>
+        </p:txBody>
+      </p:sp>
+      <p:sp>
+        <p:nvSpPr>
+          <p:cNvPr id="5" name="Shape 2"/>
           <p:cNvSpPr/>
           <p:nvPr/>
         </p:nvSpPr>
@@ -8373,7 +9894,7 @@
       </p:sp>
       <p:sp>
         <p:nvSpPr>
-          <p:cNvPr id="14" name="Text 12"/>
+          <p:cNvPr id="6" name="Text 3"/>
           <p:cNvSpPr txBox="1"/>
           <p:nvPr/>
         </p:nvSpPr>
@@ -8396,7 +9917,7 @@
               <a:buNone/>
             </a:pPr>
             <a:r>
-              <a:rPr lang="en-US" sz="3000" b="1" dirty="0">
+              <a:rPr lang="en-US" sz="2200" b="1" dirty="0">
                 <a:solidFill>
                   <a:srgbClr val="0E1752"/>
                 </a:solidFill>
@@ -8404,15 +9925,15 @@
                 <a:ea typeface="Cambria" pitchFamily="34" charset="-122"/>
                 <a:cs typeface="Cambria" pitchFamily="34" charset="-120"/>
               </a:rPr>
-              <a:t>14 h al mes</a:t>
+              <a:t>Soporte: 14 h al mes</a:t>
             </a:r>
-            <a:endParaRPr lang="en-US" sz="3000" dirty="0"/>
-          </a:p>
-        </p:txBody>
-      </p:sp>
-      <p:sp>
-        <p:nvSpPr>
-          <p:cNvPr id="15" name="Text 13"/>
+            <a:endParaRPr lang="en-US" sz="2200" dirty="0"/>
+          </a:p>
+        </p:txBody>
+      </p:sp>
+      <p:sp>
+        <p:nvSpPr>
+          <p:cNvPr id="7" name="Text 4"/>
           <p:cNvSpPr txBox="1"/>
           <p:nvPr/>
         </p:nvSpPr>
@@ -8632,7 +10153,7 @@
         </p:nvGraphicFramePr>
         <p:xfrm>
           <a:off x="457200" y="1097280"/>
-          <a:ext cx="5120640" cy="3520440"/>
+          <a:ext cx="4800600" cy="3520440"/>
         </p:xfrm>
         <a:graphic xmlns:a="http://schemas.openxmlformats.org/drawingml/2006/main">
           <a:graphicData uri="http://schemas.openxmlformats.org/drawingml/2006/chart">
@@ -8655,18 +10176,19 @@
           </p:nvPr>
         </p:nvGraphicFramePr>
         <p:xfrm>
-          <a:off x="5943600" y="1188720"/>
-          <a:ext cx="2743200" cy="914400"/>
+          <a:off x="5440680" y="1188720"/>
+          <a:ext cx="3246120" cy="914400"/>
         </p:xfrm>
         <a:graphic>
           <a:graphicData uri="http://schemas.openxmlformats.org/drawingml/2006/table">
             <a:tbl>
               <a:tblPr/>
               <a:tblGrid>
-                <a:gridCol w="1371600"/>
-                <a:gridCol w="1371600"/>
+                <a:gridCol w="1188720"/>
+                <a:gridCol w="731520"/>
+                <a:gridCol w="1325880"/>
               </a:tblGrid>
-              <a:tr h="438912">
+              <a:tr h="420624">
                 <a:tc>
                   <a:txBody>
                     <a:bodyPr/>
@@ -8675,6 +10197,17 @@
                       <a:pPr indent="0" marL="0">
                         <a:buNone/>
                       </a:pPr>
+                      <a:r>
+                        <a:rPr lang="en-US" sz="1300" b="1" dirty="0">
+                          <a:solidFill>
+                            <a:srgbClr val="FFFFFF"/>
+                          </a:solidFill>
+                          <a:latin typeface="Calibri" pitchFamily="34" charset="0"/>
+                          <a:ea typeface="Calibri" pitchFamily="34" charset="-122"/>
+                          <a:cs typeface="Calibri" pitchFamily="34" charset="-120"/>
+                        </a:rPr>
+                        <a:t>En un año</a:t>
+                      </a:r>
                       <a:endParaRPr lang="en-US" sz="1300" dirty="0">
                         <a:latin typeface="Calibri" charset="0"/>
                         <a:ea typeface="Calibri" charset="0"/>
@@ -8741,7 +10274,7 @@
                           <a:ea typeface="Calibri" pitchFamily="34" charset="-122"/>
                           <a:cs typeface="Calibri" pitchFamily="34" charset="-120"/>
                         </a:rPr>
-                        <a:t>Por hora de soporte</a:t>
+                        <a:t>Cobro</a:t>
                       </a:r>
                       <a:endParaRPr lang="en-US" sz="1300" dirty="0">
                         <a:latin typeface="Calibri" charset="0"/>
@@ -8792,8 +10325,6 @@
                     </a:solidFill>
                   </a:tcPr>
                 </a:tc>
-              </a:tr>
-              <a:tr h="438912">
                 <a:tc>
                   <a:txBody>
                     <a:bodyPr/>
@@ -8803,7 +10334,77 @@
                         <a:buNone/>
                       </a:pPr>
                       <a:r>
-                        <a:rPr lang="en-US" sz="1400" dirty="0">
+                        <a:rPr lang="en-US" sz="1300" b="1" dirty="0">
+                          <a:solidFill>
+                            <a:srgbClr val="FFFFFF"/>
+                          </a:solidFill>
+                          <a:latin typeface="Calibri" pitchFamily="34" charset="0"/>
+                          <a:ea typeface="Calibri" pitchFamily="34" charset="-122"/>
+                          <a:cs typeface="Calibri" pitchFamily="34" charset="-120"/>
+                        </a:rPr>
+                        <a:t>Queda</a:t>
+                      </a:r>
+                      <a:endParaRPr lang="en-US" sz="1300" dirty="0">
+                        <a:latin typeface="Calibri" charset="0"/>
+                        <a:ea typeface="Calibri" charset="0"/>
+                        <a:cs typeface="Calibri" charset="0"/>
+                      </a:endParaRPr>
+                    </a:p>
+                  </a:txBody>
+                  <a:tcPr marL="91440" marR="91440" marT="45720" marB="45720" anchor="ctr">
+                    <a:lnL w="9525" cap="flat" cmpd="sng" algn="ctr">
+                      <a:solidFill>
+                        <a:srgbClr val="CBD8EA"/>
+                      </a:solidFill>
+                      <a:prstDash val="solid"/>
+                      <a:round/>
+                      <a:headEnd type="none" w="med" len="med"/>
+                      <a:tailEnd type="none" w="med" len="med"/>
+                    </a:lnL>
+                    <a:lnR w="9525" cap="flat" cmpd="sng" algn="ctr">
+                      <a:solidFill>
+                        <a:srgbClr val="CBD8EA"/>
+                      </a:solidFill>
+                      <a:prstDash val="solid"/>
+                      <a:round/>
+                      <a:headEnd type="none" w="med" len="med"/>
+                      <a:tailEnd type="none" w="med" len="med"/>
+                    </a:lnR>
+                    <a:lnT w="9525" cap="flat" cmpd="sng" algn="ctr">
+                      <a:solidFill>
+                        <a:srgbClr val="CBD8EA"/>
+                      </a:solidFill>
+                      <a:prstDash val="solid"/>
+                      <a:round/>
+                      <a:headEnd type="none" w="med" len="med"/>
+                      <a:tailEnd type="none" w="med" len="med"/>
+                    </a:lnT>
+                    <a:lnB w="9525" cap="flat" cmpd="sng" algn="ctr">
+                      <a:solidFill>
+                        <a:srgbClr val="CBD8EA"/>
+                      </a:solidFill>
+                      <a:prstDash val="solid"/>
+                      <a:round/>
+                      <a:headEnd type="none" w="med" len="med"/>
+                      <a:tailEnd type="none" w="med" len="med"/>
+                    </a:lnB>
+                    <a:solidFill>
+                      <a:srgbClr val="0E1752"/>
+                    </a:solidFill>
+                  </a:tcPr>
+                </a:tc>
+              </a:tr>
+              <a:tr h="420624">
+                <a:tc>
+                  <a:txBody>
+                    <a:bodyPr/>
+                    <a:lstStyle/>
+                    <a:p>
+                      <a:pPr indent="0" marL="0">
+                        <a:buNone/>
+                      </a:pPr>
+                      <a:r>
+                        <a:rPr lang="en-US" sz="1200" dirty="0">
                           <a:solidFill>
                             <a:srgbClr val="14183A"/>
                           </a:solidFill>
@@ -8811,9 +10412,9 @@
                           <a:ea typeface="Calibri" pitchFamily="34" charset="-122"/>
                           <a:cs typeface="Calibri" pitchFamily="34" charset="-120"/>
                         </a:rPr>
-                        <a:t>Precio estimado</a:t>
+                        <a:t>Estimado</a:t>
                       </a:r>
-                      <a:endParaRPr lang="en-US" sz="1400" dirty="0">
+                      <a:endParaRPr lang="en-US" sz="1200" dirty="0">
                         <a:latin typeface="Calibri" charset="0"/>
                         <a:ea typeface="Calibri" charset="0"/>
                         <a:cs typeface="Calibri" charset="0"/>
@@ -8868,7 +10469,7 @@
                         <a:buNone/>
                       </a:pPr>
                       <a:r>
-                        <a:rPr lang="en-US" sz="1400" dirty="0">
+                        <a:rPr lang="en-US" sz="1200" dirty="0">
                           <a:solidFill>
                             <a:srgbClr val="14183A"/>
                           </a:solidFill>
@@ -8876,76 +10477,9 @@
                           <a:ea typeface="Calibri" pitchFamily="34" charset="-122"/>
                           <a:cs typeface="Calibri" pitchFamily="34" charset="-120"/>
                         </a:rPr>
-                        <a:t>$6 a $8</a:t>
+                        <a:t>$1.560</a:t>
                       </a:r>
-                      <a:endParaRPr lang="en-US" sz="1400" dirty="0">
-                        <a:latin typeface="Calibri" charset="0"/>
-                        <a:ea typeface="Calibri" charset="0"/>
-                        <a:cs typeface="Calibri" charset="0"/>
-                      </a:endParaRPr>
-                    </a:p>
-                  </a:txBody>
-                  <a:tcPr marL="91440" marR="91440" marT="45720" marB="45720" anchor="ctr">
-                    <a:lnL w="9525" cap="flat" cmpd="sng" algn="ctr">
-                      <a:solidFill>
-                        <a:srgbClr val="CBD8EA"/>
-                      </a:solidFill>
-                      <a:prstDash val="solid"/>
-                      <a:round/>
-                      <a:headEnd type="none" w="med" len="med"/>
-                      <a:tailEnd type="none" w="med" len="med"/>
-                    </a:lnL>
-                    <a:lnR w="9525" cap="flat" cmpd="sng" algn="ctr">
-                      <a:solidFill>
-                        <a:srgbClr val="CBD8EA"/>
-                      </a:solidFill>
-                      <a:prstDash val="solid"/>
-                      <a:round/>
-                      <a:headEnd type="none" w="med" len="med"/>
-                      <a:tailEnd type="none" w="med" len="med"/>
-                    </a:lnR>
-                    <a:lnT w="9525" cap="flat" cmpd="sng" algn="ctr">
-                      <a:solidFill>
-                        <a:srgbClr val="CBD8EA"/>
-                      </a:solidFill>
-                      <a:prstDash val="solid"/>
-                      <a:round/>
-                      <a:headEnd type="none" w="med" len="med"/>
-                      <a:tailEnd type="none" w="med" len="med"/>
-                    </a:lnT>
-                    <a:lnB w="9525" cap="flat" cmpd="sng" algn="ctr">
-                      <a:solidFill>
-                        <a:srgbClr val="CBD8EA"/>
-                      </a:solidFill>
-                      <a:prstDash val="solid"/>
-                      <a:round/>
-                      <a:headEnd type="none" w="med" len="med"/>
-                      <a:tailEnd type="none" w="med" len="med"/>
-                    </a:lnB>
-                  </a:tcPr>
-                </a:tc>
-              </a:tr>
-              <a:tr h="438912">
-                <a:tc>
-                  <a:txBody>
-                    <a:bodyPr/>
-                    <a:lstStyle/>
-                    <a:p>
-                      <a:pPr indent="0" marL="0">
-                        <a:buNone/>
-                      </a:pPr>
-                      <a:r>
-                        <a:rPr lang="en-US" sz="1400" dirty="0">
-                          <a:solidFill>
-                            <a:srgbClr val="14183A"/>
-                          </a:solidFill>
-                          <a:latin typeface="Calibri" pitchFamily="34" charset="0"/>
-                          <a:ea typeface="Calibri" pitchFamily="34" charset="-122"/>
-                          <a:cs typeface="Calibri" pitchFamily="34" charset="-120"/>
-                        </a:rPr>
-                        <a:t>Opción A</a:t>
-                      </a:r>
-                      <a:endParaRPr lang="en-US" sz="1400" dirty="0">
+                      <a:endParaRPr lang="en-US" sz="1200" dirty="0">
                         <a:latin typeface="Calibri" charset="0"/>
                         <a:ea typeface="Calibri" charset="0"/>
                         <a:cs typeface="Calibri" charset="0"/>
@@ -9000,7 +10534,7 @@
                         <a:buNone/>
                       </a:pPr>
                       <a:r>
-                        <a:rPr lang="en-US" sz="1400" dirty="0">
+                        <a:rPr lang="en-US" sz="1200" dirty="0">
                           <a:solidFill>
                             <a:srgbClr val="14183A"/>
                           </a:solidFill>
@@ -9008,9 +10542,9 @@
                           <a:ea typeface="Calibri" pitchFamily="34" charset="-122"/>
                           <a:cs typeface="Calibri" pitchFamily="34" charset="-120"/>
                         </a:rPr>
-                        <a:t>$3 a $5</a:t>
+                        <a:t>$1.008 a $1.308</a:t>
                       </a:r>
-                      <a:endParaRPr lang="en-US" sz="1400" dirty="0">
+                      <a:endParaRPr lang="en-US" sz="1200" dirty="0">
                         <a:latin typeface="Calibri" charset="0"/>
                         <a:ea typeface="Calibri" charset="0"/>
                         <a:cs typeface="Calibri" charset="0"/>
@@ -9057,7 +10591,7 @@
                   </a:tcPr>
                 </a:tc>
               </a:tr>
-              <a:tr h="438912">
+              <a:tr h="420624">
                 <a:tc>
                   <a:txBody>
                     <a:bodyPr/>
@@ -9067,7 +10601,7 @@
                         <a:buNone/>
                       </a:pPr>
                       <a:r>
-                        <a:rPr lang="en-US" sz="1400" dirty="0">
+                        <a:rPr lang="en-US" sz="1200" dirty="0">
                           <a:solidFill>
                             <a:srgbClr val="14183A"/>
                           </a:solidFill>
@@ -9075,9 +10609,9 @@
                           <a:ea typeface="Calibri" pitchFamily="34" charset="-122"/>
                           <a:cs typeface="Calibri" pitchFamily="34" charset="-120"/>
                         </a:rPr>
-                        <a:t>Opción B</a:t>
+                        <a:t>Opción A</a:t>
                       </a:r>
-                      <a:endParaRPr lang="en-US" sz="1400" dirty="0">
+                      <a:endParaRPr lang="en-US" sz="1200" dirty="0">
                         <a:latin typeface="Calibri" charset="0"/>
                         <a:ea typeface="Calibri" charset="0"/>
                         <a:cs typeface="Calibri" charset="0"/>
@@ -9132,7 +10666,7 @@
                         <a:buNone/>
                       </a:pPr>
                       <a:r>
-                        <a:rPr lang="en-US" sz="1400" dirty="0">
+                        <a:rPr lang="en-US" sz="1200" dirty="0">
                           <a:solidFill>
                             <a:srgbClr val="14183A"/>
                           </a:solidFill>
@@ -9140,9 +10674,9 @@
                           <a:ea typeface="Calibri" pitchFamily="34" charset="-122"/>
                           <a:cs typeface="Calibri" pitchFamily="34" charset="-120"/>
                         </a:rPr>
-                        <a:t>casi $0</a:t>
+                        <a:t>$1.080</a:t>
                       </a:r>
-                      <a:endParaRPr lang="en-US" sz="1400" dirty="0">
+                      <a:endParaRPr lang="en-US" sz="1200" dirty="0">
                         <a:latin typeface="Calibri" charset="0"/>
                         <a:ea typeface="Calibri" charset="0"/>
                         <a:cs typeface="Calibri" charset="0"/>
@@ -9188,6 +10722,465 @@
                     </a:lnB>
                   </a:tcPr>
                 </a:tc>
+                <a:tc>
+                  <a:txBody>
+                    <a:bodyPr/>
+                    <a:lstStyle/>
+                    <a:p>
+                      <a:pPr indent="0" marL="0">
+                        <a:buNone/>
+                      </a:pPr>
+                      <a:r>
+                        <a:rPr lang="en-US" sz="1200" dirty="0">
+                          <a:solidFill>
+                            <a:srgbClr val="14183A"/>
+                          </a:solidFill>
+                          <a:latin typeface="Calibri" pitchFamily="34" charset="0"/>
+                          <a:ea typeface="Calibri" pitchFamily="34" charset="-122"/>
+                          <a:cs typeface="Calibri" pitchFamily="34" charset="-120"/>
+                        </a:rPr>
+                        <a:t>$528 a $828</a:t>
+                      </a:r>
+                      <a:endParaRPr lang="en-US" sz="1200" dirty="0">
+                        <a:latin typeface="Calibri" charset="0"/>
+                        <a:ea typeface="Calibri" charset="0"/>
+                        <a:cs typeface="Calibri" charset="0"/>
+                      </a:endParaRPr>
+                    </a:p>
+                  </a:txBody>
+                  <a:tcPr marL="91440" marR="91440" marT="45720" marB="45720" anchor="ctr">
+                    <a:lnL w="9525" cap="flat" cmpd="sng" algn="ctr">
+                      <a:solidFill>
+                        <a:srgbClr val="CBD8EA"/>
+                      </a:solidFill>
+                      <a:prstDash val="solid"/>
+                      <a:round/>
+                      <a:headEnd type="none" w="med" len="med"/>
+                      <a:tailEnd type="none" w="med" len="med"/>
+                    </a:lnL>
+                    <a:lnR w="9525" cap="flat" cmpd="sng" algn="ctr">
+                      <a:solidFill>
+                        <a:srgbClr val="CBD8EA"/>
+                      </a:solidFill>
+                      <a:prstDash val="solid"/>
+                      <a:round/>
+                      <a:headEnd type="none" w="med" len="med"/>
+                      <a:tailEnd type="none" w="med" len="med"/>
+                    </a:lnR>
+                    <a:lnT w="9525" cap="flat" cmpd="sng" algn="ctr">
+                      <a:solidFill>
+                        <a:srgbClr val="CBD8EA"/>
+                      </a:solidFill>
+                      <a:prstDash val="solid"/>
+                      <a:round/>
+                      <a:headEnd type="none" w="med" len="med"/>
+                      <a:tailEnd type="none" w="med" len="med"/>
+                    </a:lnT>
+                    <a:lnB w="9525" cap="flat" cmpd="sng" algn="ctr">
+                      <a:solidFill>
+                        <a:srgbClr val="CBD8EA"/>
+                      </a:solidFill>
+                      <a:prstDash val="solid"/>
+                      <a:round/>
+                      <a:headEnd type="none" w="med" len="med"/>
+                      <a:tailEnd type="none" w="med" len="med"/>
+                    </a:lnB>
+                  </a:tcPr>
+                </a:tc>
+              </a:tr>
+              <a:tr h="420624">
+                <a:tc>
+                  <a:txBody>
+                    <a:bodyPr/>
+                    <a:lstStyle/>
+                    <a:p>
+                      <a:pPr indent="0" marL="0">
+                        <a:buNone/>
+                      </a:pPr>
+                      <a:r>
+                        <a:rPr lang="en-US" sz="1200" dirty="0">
+                          <a:solidFill>
+                            <a:srgbClr val="14183A"/>
+                          </a:solidFill>
+                          <a:latin typeface="Calibri" pitchFamily="34" charset="0"/>
+                          <a:ea typeface="Calibri" pitchFamily="34" charset="-122"/>
+                          <a:cs typeface="Calibri" pitchFamily="34" charset="-120"/>
+                        </a:rPr>
+                        <a:t>Opción B, año 1</a:t>
+                      </a:r>
+                      <a:endParaRPr lang="en-US" sz="1200" dirty="0">
+                        <a:latin typeface="Calibri" charset="0"/>
+                        <a:ea typeface="Calibri" charset="0"/>
+                        <a:cs typeface="Calibri" charset="0"/>
+                      </a:endParaRPr>
+                    </a:p>
+                  </a:txBody>
+                  <a:tcPr marL="91440" marR="91440" marT="45720" marB="45720" anchor="ctr">
+                    <a:lnL w="9525" cap="flat" cmpd="sng" algn="ctr">
+                      <a:solidFill>
+                        <a:srgbClr val="CBD8EA"/>
+                      </a:solidFill>
+                      <a:prstDash val="solid"/>
+                      <a:round/>
+                      <a:headEnd type="none" w="med" len="med"/>
+                      <a:tailEnd type="none" w="med" len="med"/>
+                    </a:lnL>
+                    <a:lnR w="9525" cap="flat" cmpd="sng" algn="ctr">
+                      <a:solidFill>
+                        <a:srgbClr val="CBD8EA"/>
+                      </a:solidFill>
+                      <a:prstDash val="solid"/>
+                      <a:round/>
+                      <a:headEnd type="none" w="med" len="med"/>
+                      <a:tailEnd type="none" w="med" len="med"/>
+                    </a:lnR>
+                    <a:lnT w="9525" cap="flat" cmpd="sng" algn="ctr">
+                      <a:solidFill>
+                        <a:srgbClr val="CBD8EA"/>
+                      </a:solidFill>
+                      <a:prstDash val="solid"/>
+                      <a:round/>
+                      <a:headEnd type="none" w="med" len="med"/>
+                      <a:tailEnd type="none" w="med" len="med"/>
+                    </a:lnT>
+                    <a:lnB w="9525" cap="flat" cmpd="sng" algn="ctr">
+                      <a:solidFill>
+                        <a:srgbClr val="CBD8EA"/>
+                      </a:solidFill>
+                      <a:prstDash val="solid"/>
+                      <a:round/>
+                      <a:headEnd type="none" w="med" len="med"/>
+                      <a:tailEnd type="none" w="med" len="med"/>
+                    </a:lnB>
+                  </a:tcPr>
+                </a:tc>
+                <a:tc>
+                  <a:txBody>
+                    <a:bodyPr/>
+                    <a:lstStyle/>
+                    <a:p>
+                      <a:pPr indent="0" marL="0">
+                        <a:buNone/>
+                      </a:pPr>
+                      <a:r>
+                        <a:rPr lang="en-US" sz="1200" dirty="0">
+                          <a:solidFill>
+                            <a:srgbClr val="14183A"/>
+                          </a:solidFill>
+                          <a:latin typeface="Calibri" pitchFamily="34" charset="0"/>
+                          <a:ea typeface="Calibri" pitchFamily="34" charset="-122"/>
+                          <a:cs typeface="Calibri" pitchFamily="34" charset="-120"/>
+                        </a:rPr>
+                        <a:t>$385</a:t>
+                      </a:r>
+                      <a:endParaRPr lang="en-US" sz="1200" dirty="0">
+                        <a:latin typeface="Calibri" charset="0"/>
+                        <a:ea typeface="Calibri" charset="0"/>
+                        <a:cs typeface="Calibri" charset="0"/>
+                      </a:endParaRPr>
+                    </a:p>
+                  </a:txBody>
+                  <a:tcPr marL="91440" marR="91440" marT="45720" marB="45720" anchor="ctr">
+                    <a:lnL w="9525" cap="flat" cmpd="sng" algn="ctr">
+                      <a:solidFill>
+                        <a:srgbClr val="CBD8EA"/>
+                      </a:solidFill>
+                      <a:prstDash val="solid"/>
+                      <a:round/>
+                      <a:headEnd type="none" w="med" len="med"/>
+                      <a:tailEnd type="none" w="med" len="med"/>
+                    </a:lnL>
+                    <a:lnR w="9525" cap="flat" cmpd="sng" algn="ctr">
+                      <a:solidFill>
+                        <a:srgbClr val="CBD8EA"/>
+                      </a:solidFill>
+                      <a:prstDash val="solid"/>
+                      <a:round/>
+                      <a:headEnd type="none" w="med" len="med"/>
+                      <a:tailEnd type="none" w="med" len="med"/>
+                    </a:lnR>
+                    <a:lnT w="9525" cap="flat" cmpd="sng" algn="ctr">
+                      <a:solidFill>
+                        <a:srgbClr val="CBD8EA"/>
+                      </a:solidFill>
+                      <a:prstDash val="solid"/>
+                      <a:round/>
+                      <a:headEnd type="none" w="med" len="med"/>
+                      <a:tailEnd type="none" w="med" len="med"/>
+                    </a:lnT>
+                    <a:lnB w="9525" cap="flat" cmpd="sng" algn="ctr">
+                      <a:solidFill>
+                        <a:srgbClr val="CBD8EA"/>
+                      </a:solidFill>
+                      <a:prstDash val="solid"/>
+                      <a:round/>
+                      <a:headEnd type="none" w="med" len="med"/>
+                      <a:tailEnd type="none" w="med" len="med"/>
+                    </a:lnB>
+                  </a:tcPr>
+                </a:tc>
+                <a:tc>
+                  <a:txBody>
+                    <a:bodyPr/>
+                    <a:lstStyle/>
+                    <a:p>
+                      <a:pPr indent="0" marL="0">
+                        <a:buNone/>
+                      </a:pPr>
+                      <a:r>
+                        <a:rPr lang="en-US" sz="1200" dirty="0">
+                          <a:solidFill>
+                            <a:srgbClr val="14183A"/>
+                          </a:solidFill>
+                          <a:latin typeface="Calibri" pitchFamily="34" charset="0"/>
+                          <a:ea typeface="Calibri" pitchFamily="34" charset="-122"/>
+                          <a:cs typeface="Calibri" pitchFamily="34" charset="-120"/>
+                        </a:rPr>
+                        <a:t>−$167 a $133</a:t>
+                      </a:r>
+                      <a:endParaRPr lang="en-US" sz="1200" dirty="0">
+                        <a:latin typeface="Calibri" charset="0"/>
+                        <a:ea typeface="Calibri" charset="0"/>
+                        <a:cs typeface="Calibri" charset="0"/>
+                      </a:endParaRPr>
+                    </a:p>
+                  </a:txBody>
+                  <a:tcPr marL="91440" marR="91440" marT="45720" marB="45720" anchor="ctr">
+                    <a:lnL w="9525" cap="flat" cmpd="sng" algn="ctr">
+                      <a:solidFill>
+                        <a:srgbClr val="CBD8EA"/>
+                      </a:solidFill>
+                      <a:prstDash val="solid"/>
+                      <a:round/>
+                      <a:headEnd type="none" w="med" len="med"/>
+                      <a:tailEnd type="none" w="med" len="med"/>
+                    </a:lnL>
+                    <a:lnR w="9525" cap="flat" cmpd="sng" algn="ctr">
+                      <a:solidFill>
+                        <a:srgbClr val="CBD8EA"/>
+                      </a:solidFill>
+                      <a:prstDash val="solid"/>
+                      <a:round/>
+                      <a:headEnd type="none" w="med" len="med"/>
+                      <a:tailEnd type="none" w="med" len="med"/>
+                    </a:lnR>
+                    <a:lnT w="9525" cap="flat" cmpd="sng" algn="ctr">
+                      <a:solidFill>
+                        <a:srgbClr val="CBD8EA"/>
+                      </a:solidFill>
+                      <a:prstDash val="solid"/>
+                      <a:round/>
+                      <a:headEnd type="none" w="med" len="med"/>
+                      <a:tailEnd type="none" w="med" len="med"/>
+                    </a:lnT>
+                    <a:lnB w="9525" cap="flat" cmpd="sng" algn="ctr">
+                      <a:solidFill>
+                        <a:srgbClr val="CBD8EA"/>
+                      </a:solidFill>
+                      <a:prstDash val="solid"/>
+                      <a:round/>
+                      <a:headEnd type="none" w="med" len="med"/>
+                      <a:tailEnd type="none" w="med" len="med"/>
+                    </a:lnB>
+                  </a:tcPr>
+                </a:tc>
+              </a:tr>
+              <a:tr h="420624">
+                <a:tc>
+                  <a:txBody>
+                    <a:bodyPr/>
+                    <a:lstStyle/>
+                    <a:p>
+                      <a:pPr indent="0" marL="0">
+                        <a:buNone/>
+                      </a:pPr>
+                      <a:r>
+                        <a:rPr lang="en-US" sz="1200" dirty="0">
+                          <a:solidFill>
+                            <a:srgbClr val="14183A"/>
+                          </a:solidFill>
+                          <a:latin typeface="Calibri" pitchFamily="34" charset="0"/>
+                          <a:ea typeface="Calibri" pitchFamily="34" charset="-122"/>
+                          <a:cs typeface="Calibri" pitchFamily="34" charset="-120"/>
+                        </a:rPr>
+                        <a:t>Opción B, después</a:t>
+                      </a:r>
+                      <a:endParaRPr lang="en-US" sz="1200" dirty="0">
+                        <a:latin typeface="Calibri" charset="0"/>
+                        <a:ea typeface="Calibri" charset="0"/>
+                        <a:cs typeface="Calibri" charset="0"/>
+                      </a:endParaRPr>
+                    </a:p>
+                  </a:txBody>
+                  <a:tcPr marL="91440" marR="91440" marT="45720" marB="45720" anchor="ctr">
+                    <a:lnL w="9525" cap="flat" cmpd="sng" algn="ctr">
+                      <a:solidFill>
+                        <a:srgbClr val="CBD8EA"/>
+                      </a:solidFill>
+                      <a:prstDash val="solid"/>
+                      <a:round/>
+                      <a:headEnd type="none" w="med" len="med"/>
+                      <a:tailEnd type="none" w="med" len="med"/>
+                    </a:lnL>
+                    <a:lnR w="9525" cap="flat" cmpd="sng" algn="ctr">
+                      <a:solidFill>
+                        <a:srgbClr val="CBD8EA"/>
+                      </a:solidFill>
+                      <a:prstDash val="solid"/>
+                      <a:round/>
+                      <a:headEnd type="none" w="med" len="med"/>
+                      <a:tailEnd type="none" w="med" len="med"/>
+                    </a:lnR>
+                    <a:lnT w="9525" cap="flat" cmpd="sng" algn="ctr">
+                      <a:solidFill>
+                        <a:srgbClr val="CBD8EA"/>
+                      </a:solidFill>
+                      <a:prstDash val="solid"/>
+                      <a:round/>
+                      <a:headEnd type="none" w="med" len="med"/>
+                      <a:tailEnd type="none" w="med" len="med"/>
+                    </a:lnT>
+                    <a:lnB w="9525" cap="flat" cmpd="sng" algn="ctr">
+                      <a:solidFill>
+                        <a:srgbClr val="CBD8EA"/>
+                      </a:solidFill>
+                      <a:prstDash val="solid"/>
+                      <a:round/>
+                      <a:headEnd type="none" w="med" len="med"/>
+                      <a:tailEnd type="none" w="med" len="med"/>
+                    </a:lnB>
+                  </a:tcPr>
+                </a:tc>
+                <a:tc>
+                  <a:txBody>
+                    <a:bodyPr/>
+                    <a:lstStyle/>
+                    <a:p>
+                      <a:pPr indent="0" marL="0">
+                        <a:buNone/>
+                      </a:pPr>
+                      <a:r>
+                        <a:rPr lang="en-US" sz="1200" dirty="0">
+                          <a:solidFill>
+                            <a:srgbClr val="14183A"/>
+                          </a:solidFill>
+                          <a:latin typeface="Calibri" pitchFamily="34" charset="0"/>
+                          <a:ea typeface="Calibri" pitchFamily="34" charset="-122"/>
+                          <a:cs typeface="Calibri" pitchFamily="34" charset="-120"/>
+                        </a:rPr>
+                        <a:t>$420</a:t>
+                      </a:r>
+                      <a:endParaRPr lang="en-US" sz="1200" dirty="0">
+                        <a:latin typeface="Calibri" charset="0"/>
+                        <a:ea typeface="Calibri" charset="0"/>
+                        <a:cs typeface="Calibri" charset="0"/>
+                      </a:endParaRPr>
+                    </a:p>
+                  </a:txBody>
+                  <a:tcPr marL="91440" marR="91440" marT="45720" marB="45720" anchor="ctr">
+                    <a:lnL w="9525" cap="flat" cmpd="sng" algn="ctr">
+                      <a:solidFill>
+                        <a:srgbClr val="CBD8EA"/>
+                      </a:solidFill>
+                      <a:prstDash val="solid"/>
+                      <a:round/>
+                      <a:headEnd type="none" w="med" len="med"/>
+                      <a:tailEnd type="none" w="med" len="med"/>
+                    </a:lnL>
+                    <a:lnR w="9525" cap="flat" cmpd="sng" algn="ctr">
+                      <a:solidFill>
+                        <a:srgbClr val="CBD8EA"/>
+                      </a:solidFill>
+                      <a:prstDash val="solid"/>
+                      <a:round/>
+                      <a:headEnd type="none" w="med" len="med"/>
+                      <a:tailEnd type="none" w="med" len="med"/>
+                    </a:lnR>
+                    <a:lnT w="9525" cap="flat" cmpd="sng" algn="ctr">
+                      <a:solidFill>
+                        <a:srgbClr val="CBD8EA"/>
+                      </a:solidFill>
+                      <a:prstDash val="solid"/>
+                      <a:round/>
+                      <a:headEnd type="none" w="med" len="med"/>
+                      <a:tailEnd type="none" w="med" len="med"/>
+                    </a:lnT>
+                    <a:lnB w="9525" cap="flat" cmpd="sng" algn="ctr">
+                      <a:solidFill>
+                        <a:srgbClr val="CBD8EA"/>
+                      </a:solidFill>
+                      <a:prstDash val="solid"/>
+                      <a:round/>
+                      <a:headEnd type="none" w="med" len="med"/>
+                      <a:tailEnd type="none" w="med" len="med"/>
+                    </a:lnB>
+                  </a:tcPr>
+                </a:tc>
+                <a:tc>
+                  <a:txBody>
+                    <a:bodyPr/>
+                    <a:lstStyle/>
+                    <a:p>
+                      <a:pPr indent="0" marL="0">
+                        <a:buNone/>
+                      </a:pPr>
+                      <a:r>
+                        <a:rPr lang="en-US" sz="1200" dirty="0">
+                          <a:solidFill>
+                            <a:srgbClr val="14183A"/>
+                          </a:solidFill>
+                          <a:latin typeface="Calibri" pitchFamily="34" charset="0"/>
+                          <a:ea typeface="Calibri" pitchFamily="34" charset="-122"/>
+                          <a:cs typeface="Calibri" pitchFamily="34" charset="-120"/>
+                        </a:rPr>
+                        <a:t>−$132 a $168</a:t>
+                      </a:r>
+                      <a:endParaRPr lang="en-US" sz="1200" dirty="0">
+                        <a:latin typeface="Calibri" charset="0"/>
+                        <a:ea typeface="Calibri" charset="0"/>
+                        <a:cs typeface="Calibri" charset="0"/>
+                      </a:endParaRPr>
+                    </a:p>
+                  </a:txBody>
+                  <a:tcPr marL="91440" marR="91440" marT="45720" marB="45720" anchor="ctr">
+                    <a:lnL w="9525" cap="flat" cmpd="sng" algn="ctr">
+                      <a:solidFill>
+                        <a:srgbClr val="CBD8EA"/>
+                      </a:solidFill>
+                      <a:prstDash val="solid"/>
+                      <a:round/>
+                      <a:headEnd type="none" w="med" len="med"/>
+                      <a:tailEnd type="none" w="med" len="med"/>
+                    </a:lnL>
+                    <a:lnR w="9525" cap="flat" cmpd="sng" algn="ctr">
+                      <a:solidFill>
+                        <a:srgbClr val="CBD8EA"/>
+                      </a:solidFill>
+                      <a:prstDash val="solid"/>
+                      <a:round/>
+                      <a:headEnd type="none" w="med" len="med"/>
+                      <a:tailEnd type="none" w="med" len="med"/>
+                    </a:lnR>
+                    <a:lnT w="9525" cap="flat" cmpd="sng" algn="ctr">
+                      <a:solidFill>
+                        <a:srgbClr val="CBD8EA"/>
+                      </a:solidFill>
+                      <a:prstDash val="solid"/>
+                      <a:round/>
+                      <a:headEnd type="none" w="med" len="med"/>
+                      <a:tailEnd type="none" w="med" len="med"/>
+                    </a:lnT>
+                    <a:lnB w="9525" cap="flat" cmpd="sng" algn="ctr">
+                      <a:solidFill>
+                        <a:srgbClr val="CBD8EA"/>
+                      </a:solidFill>
+                      <a:prstDash val="solid"/>
+                      <a:round/>
+                      <a:headEnd type="none" w="med" len="med"/>
+                      <a:tailEnd type="none" w="med" len="med"/>
+                    </a:lnB>
+                  </a:tcPr>
+                </a:tc>
               </a:tr>
             </a:tbl>
           </a:graphicData>
@@ -9201,8 +11194,8 @@
         </p:nvSpPr>
         <p:spPr>
           <a:xfrm>
-            <a:off x="5943600" y="3108960"/>
-            <a:ext cx="2743200" cy="822960"/>
+            <a:off x="5440680" y="3520440"/>
+            <a:ext cx="3246120" cy="914400"/>
           </a:xfrm>
           <a:prstGeom prst="rect">
             <a:avLst/>
@@ -9218,7 +11211,7 @@
               <a:buNone/>
             </a:pPr>
             <a:r>
-              <a:rPr lang="en-US" sz="1200" dirty="0">
+              <a:rPr lang="en-US" sz="1100" dirty="0">
                 <a:solidFill>
                   <a:srgbClr val="4E5A73"/>
                 </a:solidFill>
@@ -9226,9 +11219,9 @@
                 <a:ea typeface="Calibri" pitchFamily="34" charset="-122"/>
                 <a:cs typeface="Calibri" pitchFamily="34" charset="-120"/>
               </a:rPr>
-              <a:t>Lo que queda al mes dividido entre las 14 horas de soporte y actualizaciones.</a:t>
+              <a:t>Mensualidades del año menos $252 (plan gratis) o $552 (con respaldo diario). En la opción B el primer año tiene 11 mensualidades: el primer mes es gratis.</a:t>
             </a:r>
-            <a:endParaRPr lang="en-US" sz="1200" dirty="0"/>
+            <a:endParaRPr lang="en-US" sz="1100" dirty="0"/>
           </a:p>
         </p:txBody>
       </p:sp>
@@ -9618,7 +11611,7 @@
                 <a:ea typeface="Calibri" pitchFamily="34" charset="-122"/>
                 <a:cs typeface="Calibri" pitchFamily="34" charset="-120"/>
               </a:rPr>
-              <a:t>$35 al mes por dos sistemas deja entre −$11 y $14: el soporte queda sin cobrar. Al ser mes a mes, el cliente puede irse después de pagar los $550.</a:t>
+              <a:t>$35 al mes por dos sistemas deja entre −$11 y $14: el soporte queda sin cobrar. Al ser mes a mes, el cliente puede irse después de pagar los $550, y el primer mes no se cobra.</a:t>
             </a:r>
             <a:endParaRPr lang="en-US" sz="1400" dirty="0"/>
           </a:p>
@@ -9760,7 +11753,7 @@
                 <a:ea typeface="Calibri" pitchFamily="34" charset="-122"/>
                 <a:cs typeface="Calibri" pitchFamily="34" charset="-120"/>
               </a:rPr>
-              <a:t>Opción A con $60 farmacia + $45 laboratorio ($105 al mes): quedan $59 a $84 al mes. Opción B con $35 + $25 ($60 al mes) y mínimo 12 meses: quedan $14 a $39 al mes.</a:t>
+              <a:t>Opción A con $60 farmacia + $45 laboratorio ($105 al mes): quedan $59 a $84 al mes. Opción B con $35 + $25 ($60 al mes), primer mes gratis y mínimo 12 meses: quedan $14 a $39 al mes.</a:t>
             </a:r>
             <a:endParaRPr lang="en-US" sz="1400" dirty="0"/>
           </a:p>
@@ -9906,7 +11899,7 @@
                   <a:srgbClr val="BFE9EA"/>
                 </a:solidFill>
               </a:rPr>
-              <a:t>$60 farmacia + $45 laboratorio al mes, sin pago inicial y CrossFit gratis. Con pago inicial: $300 + $250, con $35 + $25 al mes y mínimo 12 meses. Los tres sistemas funcionando en 9 semanas.</a:t>
+              <a:t>$60 farmacia + $45 laboratorio al mes, sin pago inicial y CrossFit gratis. Con pago inicial: $300 + $250, primer mes gratis, luego $35 + $25 al mes y mínimo 12 meses. Los tres sistemas funcionando en 9 semanas.</a:t>
             </a:r>
             <a:endParaRPr lang="en-US" sz="1800" dirty="0"/>
           </a:p>
@@ -14945,7 +16938,7 @@
                 <a:ea typeface="Cambria" pitchFamily="34" charset="-122"/>
                 <a:cs typeface="Cambria" pitchFamily="34" charset="-120"/>
               </a:rPr>
-              <a:t>$970</a:t>
+              <a:t>$935</a:t>
             </a:r>
             <a:endParaRPr lang="en-US" sz="2400" dirty="0"/>
           </a:p>
@@ -14984,7 +16977,7 @@
                 <a:ea typeface="Calibri" pitchFamily="34" charset="-122"/>
                 <a:cs typeface="Calibri" pitchFamily="34" charset="-120"/>
               </a:rPr>
-              <a:t>Sin renovación anual: mes a mes, se puede ir cuando quiera</a:t>
+              <a:t>Primer mes gratis en todo · sin renovación anual, mes a mes</a:t>
             </a:r>
             <a:endParaRPr lang="en-US" sz="1200" dirty="0"/>
           </a:p>
@@ -15530,7 +17523,7 @@
                 <a:ea typeface="Cambria" pitchFamily="34" charset="-122"/>
                 <a:cs typeface="Cambria" pitchFamily="34" charset="-120"/>
               </a:rPr>
-              <a:t>$1.810</a:t>
+              <a:t>$1.775</a:t>
             </a:r>
             <a:endParaRPr lang="en-US" sz="2800" dirty="0"/>
           </a:p>
@@ -15569,7 +17562,7 @@
                 <a:ea typeface="Calibri" pitchFamily="34" charset="-122"/>
                 <a:cs typeface="Calibri" pitchFamily="34" charset="-120"/>
               </a:rPr>
-              <a:t>3 años con la opción B (-70 %)</a:t>
+              <a:t>3 años con la opción B (-71 %)</a:t>
             </a:r>
             <a:endParaRPr lang="en-US" sz="1200" dirty="0"/>
           </a:p>

</xml_diff>